<commit_message>
Update pitch deck based on client feedback
- Slide 2: Replace "No live information" with "No online booking" (more restaurant-relevant)
- Slide 7: Update photography list — terrace, interior, seafront, dishes, exterior
- Slide 8: Remove Privacy/Legal and Webcam steps, add ResDiary booking link and gift card process

Co-Authored-By: Claude Opus 4.6 <noreply@anthropic.com>
Claude-Session: https://claude.ai/code/session_012ZbjzZ7aoL8AUKXKQXjSCU
</commit_message>
<xml_diff>
--- a/SeaShanty_Redesign_Pitch.pptx
+++ b/SeaShanty_Redesign_Pitch.pptx
@@ -115,47 +115,47 @@
   <p:extLst>
     <p:ext uri="{521415D9-36F7-43E2-AB2F-B90AF26B5E84}">
       <p14:sectionLst xmlns:p14="http://schemas.microsoft.com/office/powerpoint/2010/main">
-        <p14:section name="Introduction" id="{5f2f25ed-70d1-7825-6152-a13aa6e02766}">
+        <p14:section name="Introduction" id="{6d5a1640-c1af-28b3-061e-39d16fe597fe}">
           <p14:sldIdLst>
             <p14:sldId id="256"/>
           </p14:sldIdLst>
         </p14:section>
-        <p14:section name="The Problem" id="{c6e0b2a0-834e-551f-6837-454b76139ba8}">
+        <p14:section name="The Problem" id="{f21ca360-7b4a-871e-b7c5-46ca7db64f5d}">
           <p14:sldIdLst>
             <p14:sldId id="257"/>
           </p14:sldIdLst>
         </p14:section>
-        <p14:section name="Before and After" id="{c49f5ba2-5f3e-7c96-4f57-b730b87236ff}">
+        <p14:section name="Before and After" id="{c85e3cdd-96d2-99e3-8a93-de2650b0328d}">
           <p14:sldIdLst>
             <p14:sldId id="258"/>
           </p14:sldIdLst>
         </p14:section>
-        <p14:section name="Why It Matters" id="{8b5ccb93-2199-81b9-379b-b8b1885d792c}">
+        <p14:section name="Why It Matters" id="{10f42947-6733-ce31-00bd-8d8e25685262}">
           <p14:sldIdLst>
             <p14:sldId id="259"/>
           </p14:sldIdLst>
         </p14:section>
-        <p14:section name="What's Included" id="{c315dba4-3303-4cce-91ae-952226bbc6b6}">
+        <p14:section name="What's Included" id="{a51e2817-992e-ab84-12a4-fc6ef3267bb5}">
           <p14:sldIdLst>
             <p14:sldId id="260"/>
           </p14:sldIdLst>
         </p14:section>
-        <p14:section name="Key Features" id="{8d04b276-ec38-7a88-52ee-e190fc0f8237}">
+        <p14:section name="Key Features" id="{71a44f45-59e7-5549-4209-5ee6ac7cc998}">
           <p14:sldIdLst>
             <p14:sldId id="261"/>
           </p14:sldIdLst>
         </p14:section>
-        <p14:section name="Photography" id="{c19c1ca6-a848-176b-36e8-183c81ddca0d}">
+        <p14:section name="Photography" id="{57090940-74b8-5668-e182-8c16f99bc517}">
           <p14:sldIdLst>
             <p14:sldId id="262"/>
           </p14:sldIdLst>
         </p14:section>
-        <p14:section name="Next Steps" id="{7a523aba-1d30-6e7a-fccf-f2ca0a284e74}">
+        <p14:section name="Next Steps" id="{76b6e4b5-278e-2e3e-b546-bfcebe7701a1}">
           <p14:sldIdLst>
             <p14:sldId id="263"/>
           </p14:sldIdLst>
         </p14:section>
-        <p14:section name="Closing" id="{05986ecd-02dc-1733-7ecd-1154c948c627}">
+        <p14:section name="Closing" id="{e51e8344-2597-3cbc-b611-ed90f9bb7ecd}">
           <p14:sldIdLst>
             <p14:sldId id="264"/>
           </p14:sldIdLst>
@@ -1180,7 +1180,7 @@
           <a:p>
             <a:r>
               <a:rPr lang="en-US" dirty="0"/>
-              <a:t>Run through each step. Emphasise that most items are quick — a menu PDF and opening hours are all that's essential. Photography and webcam can come later.</a:t>
+              <a:t>Run through each step. Emphasise that most items are quick — a menu PDF, opening hours, and the ResDiary link are the essentials. Gift cards and photography can follow.</a:t>
             </a:r>
             <a:endParaRPr lang="en-US" dirty="0"/>
           </a:p>
@@ -2513,7 +2513,7 @@
                   <a:srgbClr val="062F45"/>
                 </a:solidFill>
               </a:rPr>
-              <a:t>No live information</a:t>
+              <a:t>No online booking</a:t>
             </a:r>
             <a:endParaRPr lang="en-US" sz="1600" dirty="0"/>
           </a:p>
@@ -2527,7 +2527,7 @@
                   <a:srgbClr val="3D5A80"/>
                 </a:solidFill>
               </a:rPr>
-              <a:t>Customers can't see if you're open right now, what today's tides are, or check the webcam</a:t>
+              <a:t>Customers can't book a table, check the menu, or see if you're open — they have to ring up instead</a:t>
             </a:r>
             <a:endParaRPr lang="en-US" sz="1600" dirty="0"/>
           </a:p>
@@ -5456,7 +5456,7 @@
                   <a:srgbClr val="3D5A80"/>
                 </a:solidFill>
               </a:rPr>
-              <a:t>Hero shot — the bay view from the terrace</a:t>
+              <a:t>The terrace — outdoor seating and atmosphere</a:t>
             </a:r>
             <a:endParaRPr lang="en-US" sz="1200" dirty="0"/>
           </a:p>
@@ -5474,7 +5474,7 @@
                   <a:srgbClr val="3D5A80"/>
                 </a:solidFill>
               </a:rPr>
-              <a:t>3–5 signature dishes, plated and styled</a:t>
+              <a:t>The restaurant interior — decor, the bar, table settings</a:t>
             </a:r>
             <a:endParaRPr lang="en-US" sz="1200" dirty="0"/>
           </a:p>
@@ -5492,7 +5492,25 @@
                   <a:srgbClr val="3D5A80"/>
                 </a:solidFill>
               </a:rPr>
-              <a:t>Interior — atmosphere, decor, the bar</a:t>
+              <a:t>The seafront nearby — the setting and surroundings</a:t>
+            </a:r>
+            <a:endParaRPr lang="en-US" sz="1200" dirty="0"/>
+          </a:p>
+          <a:p>
+            <a:pPr marL="342900" indent="-342900">
+              <a:spcAft>
+                <a:spcPts val="400"/>
+              </a:spcAft>
+              <a:buSzPct val="100000"/>
+              <a:buChar char="•"/>
+            </a:pPr>
+            <a:r>
+              <a:rPr lang="en-US" sz="1200" dirty="0">
+                <a:solidFill>
+                  <a:srgbClr val="3D5A80"/>
+                </a:solidFill>
+              </a:rPr>
+              <a:t>3–5 signature dishes, plated and styled</a:t>
             </a:r>
             <a:endParaRPr lang="en-US" sz="1200" dirty="0"/>
           </a:p>
@@ -5799,7 +5817,7 @@
                   <a:srgbClr val="3D5A80"/>
                 </a:solidFill>
               </a:rPr>
-              <a:t>  —  Send across the current menu so we can upload the PDF download</a:t>
+              <a:t>  —  Confirm the menu is up to date and send the PDF for the download button</a:t>
             </a:r>
             <a:endParaRPr lang="en-US" sz="1400" dirty="0"/>
           </a:p>
@@ -6040,7 +6058,7 @@
                   <a:srgbClr val="062F45"/>
                 </a:solidFill>
               </a:rPr>
-              <a:t>Privacy &amp; legal</a:t>
+              <a:t>ResDiary booking link</a:t>
             </a:r>
             <a:pPr indent="0" marL="0">
               <a:buNone/>
@@ -6051,7 +6069,7 @@
                   <a:srgbClr val="3D5A80"/>
                 </a:solidFill>
               </a:rPr>
-              <a:t>  —  Any questions about the privacy policy or cookie consent — we'll adjust as needed</a:t>
+              <a:t>  —  Provide the ResDiary link so online table reservations work from the site</a:t>
             </a:r>
             <a:endParaRPr lang="en-US" sz="1400" dirty="0"/>
           </a:p>
@@ -6166,7 +6184,7 @@
                   <a:srgbClr val="062F45"/>
                 </a:solidFill>
               </a:rPr>
-              <a:t>Photography (optional)</a:t>
+              <a:t>Gift card process</a:t>
             </a:r>
             <a:pPr indent="0" marL="0">
               <a:buNone/>
@@ -6177,7 +6195,7 @@
                   <a:srgbClr val="3D5A80"/>
                 </a:solidFill>
               </a:rPr>
-              <a:t>  —  Arrange a half-day photo shoot to replace placeholder imagery</a:t>
+              <a:t>  —  Set up the gift card purchase flow — provider, pricing, and redemption details</a:t>
             </a:r>
             <a:endParaRPr lang="en-US" sz="1400" dirty="0"/>
           </a:p>
@@ -6292,7 +6310,7 @@
                   <a:srgbClr val="062F45"/>
                 </a:solidFill>
               </a:rPr>
-              <a:t>Webcam embed code</a:t>
+              <a:t>Photography (optional)</a:t>
             </a:r>
             <a:pPr indent="0" marL="0">
               <a:buNone/>
@@ -6303,7 +6321,7 @@
                   <a:srgbClr val="3D5A80"/>
                 </a:solidFill>
               </a:rPr>
-              <a:t>  —  Provide the webcam URL or embed code for the live bay view</a:t>
+              <a:t>  —  Arrange a half-day photo shoot to replace placeholder imagery</a:t>
             </a:r>
             <a:endParaRPr lang="en-US" sz="1400" dirty="0"/>
           </a:p>

</xml_diff>

<commit_message>
Update deck: mobile wording, What's On page, Google reviews step
- Slide 2: Reworded to "Hard to use on mobile" — booking exists but site drives people to phone
- Slide 5: Added "What's On" page to What's Included (replaced Tide Chart)
- Slide 8: Added Google account access and What's On content steps (now 8 steps)

Co-Authored-By: Claude Opus 4.6 <noreply@anthropic.com>
Claude-Session: https://claude.ai/code/session_012ZbjzZ7aoL8AUKXKQXjSCU
</commit_message>
<xml_diff>
--- a/SeaShanty_Redesign_Pitch.pptx
+++ b/SeaShanty_Redesign_Pitch.pptx
@@ -115,47 +115,47 @@
   <p:extLst>
     <p:ext uri="{521415D9-36F7-43E2-AB2F-B90AF26B5E84}">
       <p14:sectionLst xmlns:p14="http://schemas.microsoft.com/office/powerpoint/2010/main">
-        <p14:section name="Introduction" id="{6d5a1640-c1af-28b3-061e-39d16fe597fe}">
+        <p14:section name="Introduction" id="{76e6d37c-2af9-365c-a5ef-e035eb6552e9}">
           <p14:sldIdLst>
             <p14:sldId id="256"/>
           </p14:sldIdLst>
         </p14:section>
-        <p14:section name="The Problem" id="{f21ca360-7b4a-871e-b7c5-46ca7db64f5d}">
+        <p14:section name="The Problem" id="{2afa820e-2807-b66d-1db3-b43a88b35338}">
           <p14:sldIdLst>
             <p14:sldId id="257"/>
           </p14:sldIdLst>
         </p14:section>
-        <p14:section name="Before and After" id="{c85e3cdd-96d2-99e3-8a93-de2650b0328d}">
+        <p14:section name="Before and After" id="{65a3f116-5f19-685e-7a1b-5ddd3662d44c}">
           <p14:sldIdLst>
             <p14:sldId id="258"/>
           </p14:sldIdLst>
         </p14:section>
-        <p14:section name="Why It Matters" id="{10f42947-6733-ce31-00bd-8d8e25685262}">
+        <p14:section name="Why It Matters" id="{5726bb48-2710-72b7-6e13-faf7fe18c089}">
           <p14:sldIdLst>
             <p14:sldId id="259"/>
           </p14:sldIdLst>
         </p14:section>
-        <p14:section name="What's Included" id="{a51e2817-992e-ab84-12a4-fc6ef3267bb5}">
+        <p14:section name="What's Included" id="{144fc16d-62a0-520e-37f7-eb170ccdb637}">
           <p14:sldIdLst>
             <p14:sldId id="260"/>
           </p14:sldIdLst>
         </p14:section>
-        <p14:section name="Key Features" id="{71a44f45-59e7-5549-4209-5ee6ac7cc998}">
+        <p14:section name="Key Features" id="{e3d87249-1a78-4693-3c3a-9c4b71169542}">
           <p14:sldIdLst>
             <p14:sldId id="261"/>
           </p14:sldIdLst>
         </p14:section>
-        <p14:section name="Photography" id="{57090940-74b8-5668-e182-8c16f99bc517}">
+        <p14:section name="Photography" id="{f571db6c-21a1-e9cd-e35e-c3db8a393f53}">
           <p14:sldIdLst>
             <p14:sldId id="262"/>
           </p14:sldIdLst>
         </p14:section>
-        <p14:section name="Next Steps" id="{76b6e4b5-278e-2e3e-b546-bfcebe7701a1}">
+        <p14:section name="Next Steps" id="{588d90fc-c978-4b72-8f7c-4ac31f8b83fc}">
           <p14:sldIdLst>
             <p14:sldId id="263"/>
           </p14:sldIdLst>
         </p14:section>
-        <p14:section name="Closing" id="{e51e8344-2597-3cbc-b611-ed90f9bb7ecd}">
+        <p14:section name="Closing" id="{d740411c-924f-dd6f-b900-874cc49f17f1}">
           <p14:sldIdLst>
             <p14:sldId id="264"/>
           </p14:sldIdLst>
@@ -1180,7 +1180,7 @@
           <a:p>
             <a:r>
               <a:rPr lang="en-US" dirty="0"/>
-              <a:t>Run through each step. Emphasise that most items are quick — a menu PDF, opening hours, and the ResDiary link are the essentials. Gift cards and photography can follow.</a:t>
+              <a:t>Run through each step. The essentials are the menu PDF, opening hours, ResDiary link, and Google account access. Gift cards, What's On content, and photography can follow.</a:t>
             </a:r>
             <a:endParaRPr lang="en-US" dirty="0"/>
           </a:p>
@@ -2513,7 +2513,7 @@
                   <a:srgbClr val="062F45"/>
                 </a:solidFill>
               </a:rPr>
-              <a:t>No online booking</a:t>
+              <a:t>Hard to use on mobile</a:t>
             </a:r>
             <a:endParaRPr lang="en-US" sz="1600" dirty="0"/>
           </a:p>
@@ -2527,7 +2527,7 @@
                   <a:srgbClr val="3D5A80"/>
                 </a:solidFill>
               </a:rPr>
-              <a:t>Customers can't book a table, check the menu, or see if you're open — they have to ring up instead</a:t>
+              <a:t>Booking and menus exist but the site is so difficult on a phone that customers give up and ring instead</a:t>
             </a:r>
             <a:endParaRPr lang="en-US" sz="1600" dirty="0"/>
           </a:p>
@@ -4402,7 +4402,7 @@
                   <a:srgbClr val="000000"/>
                 </a:solidFill>
               </a:rPr>
-              <a:t>🌊</a:t>
+              <a:t>🎉</a:t>
             </a:r>
             <a:endParaRPr lang="en-US" sz="1600" dirty="0"/>
           </a:p>
@@ -4438,7 +4438,7 @@
                   <a:srgbClr val="062F45"/>
                 </a:solidFill>
               </a:rPr>
-              <a:t>Tide Chart</a:t>
+              <a:t>What's On</a:t>
             </a:r>
             <a:endParaRPr lang="en-US" sz="1300" dirty="0"/>
           </a:p>
@@ -4452,7 +4452,7 @@
                   <a:srgbClr val="3D5A80"/>
                 </a:solidFill>
               </a:rPr>
-              <a:t>Live tide times — useful for beachgoers planning a visit</a:t>
+              <a:t>Special menus, themed events, and seasonal weekends — keep visitors in the loop</a:t>
             </a:r>
             <a:endParaRPr lang="en-US" sz="1300" dirty="0"/>
           </a:p>
@@ -5728,8 +5728,8 @@
         </p:nvSpPr>
         <p:spPr>
           <a:xfrm>
-            <a:off x="548640" y="1417320"/>
-            <a:ext cx="365760" cy="365760"/>
+            <a:off x="548640" y="1389888"/>
+            <a:ext cx="320040" cy="320040"/>
           </a:xfrm>
           <a:prstGeom prst="ellipse">
             <a:avLst/>
@@ -5748,8 +5748,8 @@
         </p:nvSpPr>
         <p:spPr>
           <a:xfrm>
-            <a:off x="548640" y="1417320"/>
-            <a:ext cx="365760" cy="365760"/>
+            <a:off x="548640" y="1389888"/>
+            <a:ext cx="320040" cy="320040"/>
           </a:xfrm>
           <a:prstGeom prst="rect">
             <a:avLst/>
@@ -5765,14 +5765,14 @@
               <a:buNone/>
             </a:pPr>
             <a:r>
-              <a:rPr lang="en-US" sz="1400" b="1" dirty="0">
+              <a:rPr lang="en-US" sz="1200" b="1" dirty="0">
                 <a:solidFill>
                   <a:srgbClr val="FFFFFF"/>
                 </a:solidFill>
               </a:rPr>
               <a:t>1</a:t>
             </a:r>
-            <a:endParaRPr lang="en-US" sz="1400" dirty="0"/>
+            <a:endParaRPr lang="en-US" sz="1200" dirty="0"/>
           </a:p>
         </p:txBody>
       </p:sp>
@@ -5784,8 +5784,8 @@
         </p:nvSpPr>
         <p:spPr>
           <a:xfrm>
-            <a:off x="1051560" y="1417320"/>
-            <a:ext cx="7498080" cy="365760"/>
+            <a:off x="1005840" y="1371600"/>
+            <a:ext cx="7589520" cy="365760"/>
           </a:xfrm>
           <a:prstGeom prst="rect">
             <a:avLst/>
@@ -5801,7 +5801,7 @@
               <a:buNone/>
             </a:pPr>
             <a:r>
-              <a:rPr lang="en-US" sz="1400" b="1" dirty="0">
+              <a:rPr lang="en-US" sz="1300" b="1" dirty="0">
                 <a:solidFill>
                   <a:srgbClr val="062F45"/>
                 </a:solidFill>
@@ -5812,14 +5812,14 @@
               <a:buNone/>
             </a:pPr>
             <a:r>
-              <a:rPr lang="en-US" sz="1200" dirty="0">
+              <a:rPr lang="en-US" sz="1100" dirty="0">
                 <a:solidFill>
                   <a:srgbClr val="3D5A80"/>
                 </a:solidFill>
               </a:rPr>
               <a:t>  —  Confirm the menu is up to date and send the PDF for the download button</a:t>
             </a:r>
-            <a:endParaRPr lang="en-US" sz="1400" dirty="0"/>
+            <a:endParaRPr lang="en-US" sz="1300" dirty="0"/>
           </a:p>
         </p:txBody>
       </p:sp>
@@ -5831,8 +5831,8 @@
         </p:nvSpPr>
         <p:spPr>
           <a:xfrm>
-            <a:off x="731520" y="1783080"/>
-            <a:ext cx="0" cy="137160"/>
+            <a:off x="731520" y="1737360"/>
+            <a:ext cx="0" cy="36576"/>
           </a:xfrm>
           <a:prstGeom prst="line">
             <a:avLst/>
@@ -5854,8 +5854,8 @@
         </p:nvSpPr>
         <p:spPr>
           <a:xfrm>
-            <a:off x="548640" y="1920240"/>
-            <a:ext cx="365760" cy="365760"/>
+            <a:off x="548640" y="1792224"/>
+            <a:ext cx="320040" cy="320040"/>
           </a:xfrm>
           <a:prstGeom prst="ellipse">
             <a:avLst/>
@@ -5874,8 +5874,8 @@
         </p:nvSpPr>
         <p:spPr>
           <a:xfrm>
-            <a:off x="548640" y="1920240"/>
-            <a:ext cx="365760" cy="365760"/>
+            <a:off x="548640" y="1792224"/>
+            <a:ext cx="320040" cy="320040"/>
           </a:xfrm>
           <a:prstGeom prst="rect">
             <a:avLst/>
@@ -5891,14 +5891,14 @@
               <a:buNone/>
             </a:pPr>
             <a:r>
-              <a:rPr lang="en-US" sz="1400" b="1" dirty="0">
+              <a:rPr lang="en-US" sz="1200" b="1" dirty="0">
                 <a:solidFill>
                   <a:srgbClr val="FFFFFF"/>
                 </a:solidFill>
               </a:rPr>
               <a:t>2</a:t>
             </a:r>
-            <a:endParaRPr lang="en-US" sz="1400" dirty="0"/>
+            <a:endParaRPr lang="en-US" sz="1200" dirty="0"/>
           </a:p>
         </p:txBody>
       </p:sp>
@@ -5910,8 +5910,8 @@
         </p:nvSpPr>
         <p:spPr>
           <a:xfrm>
-            <a:off x="1051560" y="1920240"/>
-            <a:ext cx="7498080" cy="365760"/>
+            <a:off x="1005840" y="1773936"/>
+            <a:ext cx="7589520" cy="365760"/>
           </a:xfrm>
           <a:prstGeom prst="rect">
             <a:avLst/>
@@ -5927,7 +5927,7 @@
               <a:buNone/>
             </a:pPr>
             <a:r>
-              <a:rPr lang="en-US" sz="1400" b="1" dirty="0">
+              <a:rPr lang="en-US" sz="1300" b="1" dirty="0">
                 <a:solidFill>
                   <a:srgbClr val="062F45"/>
                 </a:solidFill>
@@ -5938,14 +5938,14 @@
               <a:buNone/>
             </a:pPr>
             <a:r>
-              <a:rPr lang="en-US" sz="1200" dirty="0">
+              <a:rPr lang="en-US" sz="1100" dirty="0">
                 <a:solidFill>
                   <a:srgbClr val="3D5A80"/>
                 </a:solidFill>
               </a:rPr>
               <a:t>  —  Provide regular hours and any seasonal variations for the live status widget</a:t>
             </a:r>
-            <a:endParaRPr lang="en-US" sz="1400" dirty="0"/>
+            <a:endParaRPr lang="en-US" sz="1300" dirty="0"/>
           </a:p>
         </p:txBody>
       </p:sp>
@@ -5957,8 +5957,8 @@
         </p:nvSpPr>
         <p:spPr>
           <a:xfrm>
-            <a:off x="731520" y="2286000"/>
-            <a:ext cx="0" cy="137160"/>
+            <a:off x="731520" y="2139696"/>
+            <a:ext cx="0" cy="36576"/>
           </a:xfrm>
           <a:prstGeom prst="line">
             <a:avLst/>
@@ -5980,8 +5980,8 @@
         </p:nvSpPr>
         <p:spPr>
           <a:xfrm>
-            <a:off x="548640" y="2423160"/>
-            <a:ext cx="365760" cy="365760"/>
+            <a:off x="548640" y="2194560"/>
+            <a:ext cx="320040" cy="320040"/>
           </a:xfrm>
           <a:prstGeom prst="ellipse">
             <a:avLst/>
@@ -6000,8 +6000,8 @@
         </p:nvSpPr>
         <p:spPr>
           <a:xfrm>
-            <a:off x="548640" y="2423160"/>
-            <a:ext cx="365760" cy="365760"/>
+            <a:off x="548640" y="2194560"/>
+            <a:ext cx="320040" cy="320040"/>
           </a:xfrm>
           <a:prstGeom prst="rect">
             <a:avLst/>
@@ -6017,14 +6017,14 @@
               <a:buNone/>
             </a:pPr>
             <a:r>
-              <a:rPr lang="en-US" sz="1400" b="1" dirty="0">
+              <a:rPr lang="en-US" sz="1200" b="1" dirty="0">
                 <a:solidFill>
                   <a:srgbClr val="FFFFFF"/>
                 </a:solidFill>
               </a:rPr>
               <a:t>3</a:t>
             </a:r>
-            <a:endParaRPr lang="en-US" sz="1400" dirty="0"/>
+            <a:endParaRPr lang="en-US" sz="1200" dirty="0"/>
           </a:p>
         </p:txBody>
       </p:sp>
@@ -6036,8 +6036,8 @@
         </p:nvSpPr>
         <p:spPr>
           <a:xfrm>
-            <a:off x="1051560" y="2423160"/>
-            <a:ext cx="7498080" cy="365760"/>
+            <a:off x="1005840" y="2176272"/>
+            <a:ext cx="7589520" cy="365760"/>
           </a:xfrm>
           <a:prstGeom prst="rect">
             <a:avLst/>
@@ -6053,7 +6053,7 @@
               <a:buNone/>
             </a:pPr>
             <a:r>
-              <a:rPr lang="en-US" sz="1400" b="1" dirty="0">
+              <a:rPr lang="en-US" sz="1300" b="1" dirty="0">
                 <a:solidFill>
                   <a:srgbClr val="062F45"/>
                 </a:solidFill>
@@ -6064,14 +6064,14 @@
               <a:buNone/>
             </a:pPr>
             <a:r>
-              <a:rPr lang="en-US" sz="1200" dirty="0">
+              <a:rPr lang="en-US" sz="1100" dirty="0">
                 <a:solidFill>
                   <a:srgbClr val="3D5A80"/>
                 </a:solidFill>
               </a:rPr>
               <a:t>  —  Provide the ResDiary link so online table reservations work from the site</a:t>
             </a:r>
-            <a:endParaRPr lang="en-US" sz="1400" dirty="0"/>
+            <a:endParaRPr lang="en-US" sz="1300" dirty="0"/>
           </a:p>
         </p:txBody>
       </p:sp>
@@ -6083,8 +6083,8 @@
         </p:nvSpPr>
         <p:spPr>
           <a:xfrm>
-            <a:off x="731520" y="2788920"/>
-            <a:ext cx="0" cy="137160"/>
+            <a:off x="731520" y="2542032"/>
+            <a:ext cx="0" cy="36576"/>
           </a:xfrm>
           <a:prstGeom prst="line">
             <a:avLst/>
@@ -6106,8 +6106,8 @@
         </p:nvSpPr>
         <p:spPr>
           <a:xfrm>
-            <a:off x="548640" y="2926080"/>
-            <a:ext cx="365760" cy="365760"/>
+            <a:off x="548640" y="2596896"/>
+            <a:ext cx="320040" cy="320040"/>
           </a:xfrm>
           <a:prstGeom prst="ellipse">
             <a:avLst/>
@@ -6126,8 +6126,8 @@
         </p:nvSpPr>
         <p:spPr>
           <a:xfrm>
-            <a:off x="548640" y="2926080"/>
-            <a:ext cx="365760" cy="365760"/>
+            <a:off x="548640" y="2596896"/>
+            <a:ext cx="320040" cy="320040"/>
           </a:xfrm>
           <a:prstGeom prst="rect">
             <a:avLst/>
@@ -6143,14 +6143,14 @@
               <a:buNone/>
             </a:pPr>
             <a:r>
-              <a:rPr lang="en-US" sz="1400" b="1" dirty="0">
+              <a:rPr lang="en-US" sz="1200" b="1" dirty="0">
                 <a:solidFill>
                   <a:srgbClr val="FFFFFF"/>
                 </a:solidFill>
               </a:rPr>
               <a:t>4</a:t>
             </a:r>
-            <a:endParaRPr lang="en-US" sz="1400" dirty="0"/>
+            <a:endParaRPr lang="en-US" sz="1200" dirty="0"/>
           </a:p>
         </p:txBody>
       </p:sp>
@@ -6162,8 +6162,8 @@
         </p:nvSpPr>
         <p:spPr>
           <a:xfrm>
-            <a:off x="1051560" y="2926080"/>
-            <a:ext cx="7498080" cy="365760"/>
+            <a:off x="1005840" y="2578608"/>
+            <a:ext cx="7589520" cy="365760"/>
           </a:xfrm>
           <a:prstGeom prst="rect">
             <a:avLst/>
@@ -6179,25 +6179,25 @@
               <a:buNone/>
             </a:pPr>
             <a:r>
-              <a:rPr lang="en-US" sz="1400" b="1" dirty="0">
+              <a:rPr lang="en-US" sz="1300" b="1" dirty="0">
                 <a:solidFill>
                   <a:srgbClr val="062F45"/>
                 </a:solidFill>
               </a:rPr>
-              <a:t>Gift card process</a:t>
-            </a:r>
-            <a:pPr indent="0" marL="0">
-              <a:buNone/>
-            </a:pPr>
-            <a:r>
-              <a:rPr lang="en-US" sz="1200" dirty="0">
+              <a:t>Google account access</a:t>
+            </a:r>
+            <a:pPr indent="0" marL="0">
+              <a:buNone/>
+            </a:pPr>
+            <a:r>
+              <a:rPr lang="en-US" sz="1100" dirty="0">
                 <a:solidFill>
                   <a:srgbClr val="3D5A80"/>
                 </a:solidFill>
               </a:rPr>
-              <a:t>  —  Set up the gift card purchase flow — provider, pricing, and redemption details</a:t>
-            </a:r>
-            <a:endParaRPr lang="en-US" sz="1400" dirty="0"/>
+              <a:t>  —  Share Google Business access so we can pull in your reviews and ratings</a:t>
+            </a:r>
+            <a:endParaRPr lang="en-US" sz="1300" dirty="0"/>
           </a:p>
         </p:txBody>
       </p:sp>
@@ -6209,8 +6209,8 @@
         </p:nvSpPr>
         <p:spPr>
           <a:xfrm>
-            <a:off x="731520" y="3291840"/>
-            <a:ext cx="0" cy="137160"/>
+            <a:off x="731520" y="2944368"/>
+            <a:ext cx="0" cy="36576"/>
           </a:xfrm>
           <a:prstGeom prst="line">
             <a:avLst/>
@@ -6232,8 +6232,8 @@
         </p:nvSpPr>
         <p:spPr>
           <a:xfrm>
-            <a:off x="548640" y="3429000"/>
-            <a:ext cx="365760" cy="365760"/>
+            <a:off x="548640" y="2999232"/>
+            <a:ext cx="320040" cy="320040"/>
           </a:xfrm>
           <a:prstGeom prst="ellipse">
             <a:avLst/>
@@ -6252,8 +6252,8 @@
         </p:nvSpPr>
         <p:spPr>
           <a:xfrm>
-            <a:off x="548640" y="3429000"/>
-            <a:ext cx="365760" cy="365760"/>
+            <a:off x="548640" y="2999232"/>
+            <a:ext cx="320040" cy="320040"/>
           </a:xfrm>
           <a:prstGeom prst="rect">
             <a:avLst/>
@@ -6269,14 +6269,14 @@
               <a:buNone/>
             </a:pPr>
             <a:r>
-              <a:rPr lang="en-US" sz="1400" b="1" dirty="0">
+              <a:rPr lang="en-US" sz="1200" b="1" dirty="0">
                 <a:solidFill>
                   <a:srgbClr val="FFFFFF"/>
                 </a:solidFill>
               </a:rPr>
               <a:t>5</a:t>
             </a:r>
-            <a:endParaRPr lang="en-US" sz="1400" dirty="0"/>
+            <a:endParaRPr lang="en-US" sz="1200" dirty="0"/>
           </a:p>
         </p:txBody>
       </p:sp>
@@ -6288,8 +6288,8 @@
         </p:nvSpPr>
         <p:spPr>
           <a:xfrm>
-            <a:off x="1051560" y="3429000"/>
-            <a:ext cx="7498080" cy="365760"/>
+            <a:off x="1005840" y="2980944"/>
+            <a:ext cx="7589520" cy="365760"/>
           </a:xfrm>
           <a:prstGeom prst="rect">
             <a:avLst/>
@@ -6305,25 +6305,25 @@
               <a:buNone/>
             </a:pPr>
             <a:r>
-              <a:rPr lang="en-US" sz="1400" b="1" dirty="0">
+              <a:rPr lang="en-US" sz="1300" b="1" dirty="0">
                 <a:solidFill>
                   <a:srgbClr val="062F45"/>
                 </a:solidFill>
               </a:rPr>
-              <a:t>Photography (optional)</a:t>
-            </a:r>
-            <a:pPr indent="0" marL="0">
-              <a:buNone/>
-            </a:pPr>
-            <a:r>
-              <a:rPr lang="en-US" sz="1200" dirty="0">
+              <a:t>Gift card process</a:t>
+            </a:r>
+            <a:pPr indent="0" marL="0">
+              <a:buNone/>
+            </a:pPr>
+            <a:r>
+              <a:rPr lang="en-US" sz="1100" dirty="0">
                 <a:solidFill>
                   <a:srgbClr val="3D5A80"/>
                 </a:solidFill>
               </a:rPr>
-              <a:t>  —  Arrange a half-day photo shoot to replace placeholder imagery</a:t>
-            </a:r>
-            <a:endParaRPr lang="en-US" sz="1400" dirty="0"/>
+              <a:t>  —  Set up the gift card purchase flow — provider, pricing, and redemption details</a:t>
+            </a:r>
+            <a:endParaRPr lang="en-US" sz="1300" dirty="0"/>
           </a:p>
         </p:txBody>
       </p:sp>
@@ -6335,8 +6335,8 @@
         </p:nvSpPr>
         <p:spPr>
           <a:xfrm>
-            <a:off x="731520" y="3794760"/>
-            <a:ext cx="0" cy="137160"/>
+            <a:off x="731520" y="3346704"/>
+            <a:ext cx="0" cy="36576"/>
           </a:xfrm>
           <a:prstGeom prst="line">
             <a:avLst/>
@@ -6358,8 +6358,260 @@
         </p:nvSpPr>
         <p:spPr>
           <a:xfrm>
-            <a:off x="548640" y="3931920"/>
-            <a:ext cx="365760" cy="365760"/>
+            <a:off x="548640" y="3401568"/>
+            <a:ext cx="320040" cy="320040"/>
+          </a:xfrm>
+          <a:prstGeom prst="ellipse">
+            <a:avLst/>
+          </a:prstGeom>
+          <a:solidFill>
+            <a:srgbClr val="062F45"/>
+          </a:solidFill>
+          <a:ln/>
+        </p:spPr>
+      </p:sp>
+      <p:sp>
+        <p:nvSpPr>
+          <p:cNvPr id="25" name="Text 23"/>
+          <p:cNvSpPr txBox="1"/>
+          <p:nvPr/>
+        </p:nvSpPr>
+        <p:spPr>
+          <a:xfrm>
+            <a:off x="548640" y="3401568"/>
+            <a:ext cx="320040" cy="320040"/>
+          </a:xfrm>
+          <a:prstGeom prst="rect">
+            <a:avLst/>
+          </a:prstGeom>
+          <a:noFill/>
+          <a:ln/>
+        </p:spPr>
+        <p:txBody>
+          <a:bodyPr wrap="square" lIns="0" tIns="0" rIns="0" bIns="0" rtlCol="0" anchor="ctr"/>
+          <a:lstStyle/>
+          <a:p>
+            <a:pPr algn="ctr" indent="0" marL="0">
+              <a:buNone/>
+            </a:pPr>
+            <a:r>
+              <a:rPr lang="en-US" sz="1200" b="1" dirty="0">
+                <a:solidFill>
+                  <a:srgbClr val="FFFFFF"/>
+                </a:solidFill>
+              </a:rPr>
+              <a:t>6</a:t>
+            </a:r>
+            <a:endParaRPr lang="en-US" sz="1200" dirty="0"/>
+          </a:p>
+        </p:txBody>
+      </p:sp>
+      <p:sp>
+        <p:nvSpPr>
+          <p:cNvPr id="26" name="Text 24"/>
+          <p:cNvSpPr txBox="1"/>
+          <p:nvPr/>
+        </p:nvSpPr>
+        <p:spPr>
+          <a:xfrm>
+            <a:off x="1005840" y="3383280"/>
+            <a:ext cx="7589520" cy="365760"/>
+          </a:xfrm>
+          <a:prstGeom prst="rect">
+            <a:avLst/>
+          </a:prstGeom>
+          <a:noFill/>
+          <a:ln/>
+        </p:spPr>
+        <p:txBody>
+          <a:bodyPr wrap="square" lIns="0" tIns="0" rIns="0" bIns="0" rtlCol="0" anchor="ctr"/>
+          <a:lstStyle/>
+          <a:p>
+            <a:pPr indent="0" marL="0">
+              <a:buNone/>
+            </a:pPr>
+            <a:r>
+              <a:rPr lang="en-US" sz="1300" b="1" dirty="0">
+                <a:solidFill>
+                  <a:srgbClr val="062F45"/>
+                </a:solidFill>
+              </a:rPr>
+              <a:t>What's On content</a:t>
+            </a:r>
+            <a:pPr indent="0" marL="0">
+              <a:buNone/>
+            </a:pPr>
+            <a:r>
+              <a:rPr lang="en-US" sz="1100" dirty="0">
+                <a:solidFill>
+                  <a:srgbClr val="3D5A80"/>
+                </a:solidFill>
+              </a:rPr>
+              <a:t>  —  Send details of upcoming events, themed nights, or special menus for the new page</a:t>
+            </a:r>
+            <a:endParaRPr lang="en-US" sz="1300" dirty="0"/>
+          </a:p>
+        </p:txBody>
+      </p:sp>
+      <p:sp>
+        <p:nvSpPr>
+          <p:cNvPr id="27" name="Shape 25"/>
+          <p:cNvSpPr/>
+          <p:nvPr/>
+        </p:nvSpPr>
+        <p:spPr>
+          <a:xfrm>
+            <a:off x="731520" y="3749040"/>
+            <a:ext cx="0" cy="36576"/>
+          </a:xfrm>
+          <a:prstGeom prst="line">
+            <a:avLst/>
+          </a:prstGeom>
+          <a:noFill/>
+          <a:ln w="19050">
+            <a:solidFill>
+              <a:srgbClr val="C3D0E5"/>
+            </a:solidFill>
+            <a:prstDash val="solid"/>
+          </a:ln>
+        </p:spPr>
+      </p:sp>
+      <p:sp>
+        <p:nvSpPr>
+          <p:cNvPr id="28" name="Shape 26"/>
+          <p:cNvSpPr/>
+          <p:nvPr/>
+        </p:nvSpPr>
+        <p:spPr>
+          <a:xfrm>
+            <a:off x="548640" y="3803904"/>
+            <a:ext cx="320040" cy="320040"/>
+          </a:xfrm>
+          <a:prstGeom prst="ellipse">
+            <a:avLst/>
+          </a:prstGeom>
+          <a:solidFill>
+            <a:srgbClr val="062F45"/>
+          </a:solidFill>
+          <a:ln/>
+        </p:spPr>
+      </p:sp>
+      <p:sp>
+        <p:nvSpPr>
+          <p:cNvPr id="29" name="Text 27"/>
+          <p:cNvSpPr txBox="1"/>
+          <p:nvPr/>
+        </p:nvSpPr>
+        <p:spPr>
+          <a:xfrm>
+            <a:off x="548640" y="3803904"/>
+            <a:ext cx="320040" cy="320040"/>
+          </a:xfrm>
+          <a:prstGeom prst="rect">
+            <a:avLst/>
+          </a:prstGeom>
+          <a:noFill/>
+          <a:ln/>
+        </p:spPr>
+        <p:txBody>
+          <a:bodyPr wrap="square" lIns="0" tIns="0" rIns="0" bIns="0" rtlCol="0" anchor="ctr"/>
+          <a:lstStyle/>
+          <a:p>
+            <a:pPr algn="ctr" indent="0" marL="0">
+              <a:buNone/>
+            </a:pPr>
+            <a:r>
+              <a:rPr lang="en-US" sz="1200" b="1" dirty="0">
+                <a:solidFill>
+                  <a:srgbClr val="FFFFFF"/>
+                </a:solidFill>
+              </a:rPr>
+              <a:t>7</a:t>
+            </a:r>
+            <a:endParaRPr lang="en-US" sz="1200" dirty="0"/>
+          </a:p>
+        </p:txBody>
+      </p:sp>
+      <p:sp>
+        <p:nvSpPr>
+          <p:cNvPr id="30" name="Text 28"/>
+          <p:cNvSpPr txBox="1"/>
+          <p:nvPr/>
+        </p:nvSpPr>
+        <p:spPr>
+          <a:xfrm>
+            <a:off x="1005840" y="3785616"/>
+            <a:ext cx="7589520" cy="365760"/>
+          </a:xfrm>
+          <a:prstGeom prst="rect">
+            <a:avLst/>
+          </a:prstGeom>
+          <a:noFill/>
+          <a:ln/>
+        </p:spPr>
+        <p:txBody>
+          <a:bodyPr wrap="square" lIns="0" tIns="0" rIns="0" bIns="0" rtlCol="0" anchor="ctr"/>
+          <a:lstStyle/>
+          <a:p>
+            <a:pPr indent="0" marL="0">
+              <a:buNone/>
+            </a:pPr>
+            <a:r>
+              <a:rPr lang="en-US" sz="1300" b="1" dirty="0">
+                <a:solidFill>
+                  <a:srgbClr val="062F45"/>
+                </a:solidFill>
+              </a:rPr>
+              <a:t>Photography (optional)</a:t>
+            </a:r>
+            <a:pPr indent="0" marL="0">
+              <a:buNone/>
+            </a:pPr>
+            <a:r>
+              <a:rPr lang="en-US" sz="1100" dirty="0">
+                <a:solidFill>
+                  <a:srgbClr val="3D5A80"/>
+                </a:solidFill>
+              </a:rPr>
+              <a:t>  —  Arrange a half-day photo shoot to replace placeholder imagery</a:t>
+            </a:r>
+            <a:endParaRPr lang="en-US" sz="1300" dirty="0"/>
+          </a:p>
+        </p:txBody>
+      </p:sp>
+      <p:sp>
+        <p:nvSpPr>
+          <p:cNvPr id="31" name="Shape 29"/>
+          <p:cNvSpPr/>
+          <p:nvPr/>
+        </p:nvSpPr>
+        <p:spPr>
+          <a:xfrm>
+            <a:off x="731520" y="4151376"/>
+            <a:ext cx="0" cy="36576"/>
+          </a:xfrm>
+          <a:prstGeom prst="line">
+            <a:avLst/>
+          </a:prstGeom>
+          <a:noFill/>
+          <a:ln w="19050">
+            <a:solidFill>
+              <a:srgbClr val="C3D0E5"/>
+            </a:solidFill>
+            <a:prstDash val="solid"/>
+          </a:ln>
+        </p:spPr>
+      </p:sp>
+      <p:sp>
+        <p:nvSpPr>
+          <p:cNvPr id="32" name="Shape 30"/>
+          <p:cNvSpPr/>
+          <p:nvPr/>
+        </p:nvSpPr>
+        <p:spPr>
+          <a:xfrm>
+            <a:off x="548640" y="4206240"/>
+            <a:ext cx="320040" cy="320040"/>
           </a:xfrm>
           <a:prstGeom prst="ellipse">
             <a:avLst/>
@@ -6372,14 +6624,14 @@
       </p:sp>
       <p:sp>
         <p:nvSpPr>
-          <p:cNvPr id="25" name="Text 23"/>
-          <p:cNvSpPr txBox="1"/>
-          <p:nvPr/>
-        </p:nvSpPr>
-        <p:spPr>
-          <a:xfrm>
-            <a:off x="548640" y="3931920"/>
-            <a:ext cx="365760" cy="365760"/>
+          <p:cNvPr id="33" name="Text 31"/>
+          <p:cNvSpPr txBox="1"/>
+          <p:nvPr/>
+        </p:nvSpPr>
+        <p:spPr>
+          <a:xfrm>
+            <a:off x="548640" y="4206240"/>
+            <a:ext cx="320040" cy="320040"/>
           </a:xfrm>
           <a:prstGeom prst="rect">
             <a:avLst/>
@@ -6395,27 +6647,27 @@
               <a:buNone/>
             </a:pPr>
             <a:r>
-              <a:rPr lang="en-US" sz="1400" b="1" dirty="0">
+              <a:rPr lang="en-US" sz="1200" b="1" dirty="0">
                 <a:solidFill>
                   <a:srgbClr val="FFFFFF"/>
                 </a:solidFill>
               </a:rPr>
-              <a:t>6</a:t>
-            </a:r>
-            <a:endParaRPr lang="en-US" sz="1400" dirty="0"/>
-          </a:p>
-        </p:txBody>
-      </p:sp>
-      <p:sp>
-        <p:nvSpPr>
-          <p:cNvPr id="26" name="Text 24"/>
-          <p:cNvSpPr txBox="1"/>
-          <p:nvPr/>
-        </p:nvSpPr>
-        <p:spPr>
-          <a:xfrm>
-            <a:off x="1051560" y="3931920"/>
-            <a:ext cx="7498080" cy="365760"/>
+              <a:t>8</a:t>
+            </a:r>
+            <a:endParaRPr lang="en-US" sz="1200" dirty="0"/>
+          </a:p>
+        </p:txBody>
+      </p:sp>
+      <p:sp>
+        <p:nvSpPr>
+          <p:cNvPr id="34" name="Text 32"/>
+          <p:cNvSpPr txBox="1"/>
+          <p:nvPr/>
+        </p:nvSpPr>
+        <p:spPr>
+          <a:xfrm>
+            <a:off x="1005840" y="4187952"/>
+            <a:ext cx="7589520" cy="365760"/>
           </a:xfrm>
           <a:prstGeom prst="rect">
             <a:avLst/>
@@ -6431,7 +6683,7 @@
               <a:buNone/>
             </a:pPr>
             <a:r>
-              <a:rPr lang="en-US" sz="1400" b="1" dirty="0">
+              <a:rPr lang="en-US" sz="1300" b="1" dirty="0">
                 <a:solidFill>
                   <a:srgbClr val="062F45"/>
                 </a:solidFill>
@@ -6442,14 +6694,14 @@
               <a:buNone/>
             </a:pPr>
             <a:r>
-              <a:rPr lang="en-US" sz="1200" dirty="0">
+              <a:rPr lang="en-US" sz="1100" dirty="0">
                 <a:solidFill>
                   <a:srgbClr val="3D5A80"/>
                 </a:solidFill>
               </a:rPr>
               <a:t>  —  Point your domain to the new site — we handle the technical switch</a:t>
             </a:r>
-            <a:endParaRPr lang="en-US" sz="1400" dirty="0"/>
+            <a:endParaRPr lang="en-US" sz="1300" dirty="0"/>
           </a:p>
         </p:txBody>
       </p:sp>

</xml_diff>

<commit_message>
Refine deck: reinstate tide times, What's On as suggestion, cleaner mobile wording
- Slide 2: Reworded to "Frustrating on mobile" — acknowledges booking exists but is unusable
- Slide 5: Tide Chart reinstated in What's Included
- Slide 8: What's On moved to a suggestion callout below the 7 steps

Co-Authored-By: Claude Opus 4.6 <noreply@anthropic.com>
Claude-Session: https://claude.ai/code/session_012ZbjzZ7aoL8AUKXKQXjSCU
</commit_message>
<xml_diff>
--- a/SeaShanty_Redesign_Pitch.pptx
+++ b/SeaShanty_Redesign_Pitch.pptx
@@ -115,47 +115,47 @@
   <p:extLst>
     <p:ext uri="{521415D9-36F7-43E2-AB2F-B90AF26B5E84}">
       <p14:sectionLst xmlns:p14="http://schemas.microsoft.com/office/powerpoint/2010/main">
-        <p14:section name="Introduction" id="{76e6d37c-2af9-365c-a5ef-e035eb6552e9}">
+        <p14:section name="Introduction" id="{636136de-b3c4-2eab-e2a6-0fd5aa7ac792}">
           <p14:sldIdLst>
             <p14:sldId id="256"/>
           </p14:sldIdLst>
         </p14:section>
-        <p14:section name="The Problem" id="{2afa820e-2807-b66d-1db3-b43a88b35338}">
+        <p14:section name="The Problem" id="{8386cdb5-af98-fee0-a793-e89ed6acde38}">
           <p14:sldIdLst>
             <p14:sldId id="257"/>
           </p14:sldIdLst>
         </p14:section>
-        <p14:section name="Before and After" id="{65a3f116-5f19-685e-7a1b-5ddd3662d44c}">
+        <p14:section name="Before and After" id="{8dd5eb94-2136-4806-e3d6-9091451dc121}">
           <p14:sldIdLst>
             <p14:sldId id="258"/>
           </p14:sldIdLst>
         </p14:section>
-        <p14:section name="Why It Matters" id="{5726bb48-2710-72b7-6e13-faf7fe18c089}">
+        <p14:section name="Why It Matters" id="{0923609d-16b2-2307-7529-ba01cf37ed02}">
           <p14:sldIdLst>
             <p14:sldId id="259"/>
           </p14:sldIdLst>
         </p14:section>
-        <p14:section name="What's Included" id="{144fc16d-62a0-520e-37f7-eb170ccdb637}">
+        <p14:section name="What's Included" id="{e5cefbaf-890d-49c9-60df-f45109d935ba}">
           <p14:sldIdLst>
             <p14:sldId id="260"/>
           </p14:sldIdLst>
         </p14:section>
-        <p14:section name="Key Features" id="{e3d87249-1a78-4693-3c3a-9c4b71169542}">
+        <p14:section name="Key Features" id="{5ba3bfc9-bf41-f344-a68c-d3af5afc2340}">
           <p14:sldIdLst>
             <p14:sldId id="261"/>
           </p14:sldIdLst>
         </p14:section>
-        <p14:section name="Photography" id="{f571db6c-21a1-e9cd-e35e-c3db8a393f53}">
+        <p14:section name="Photography" id="{78a73b39-49a2-fe61-f038-5df8e0971fa3}">
           <p14:sldIdLst>
             <p14:sldId id="262"/>
           </p14:sldIdLst>
         </p14:section>
-        <p14:section name="Next Steps" id="{588d90fc-c978-4b72-8f7c-4ac31f8b83fc}">
+        <p14:section name="Next Steps" id="{83190fb4-eef9-7594-8832-3f2aa25344fc}">
           <p14:sldIdLst>
             <p14:sldId id="263"/>
           </p14:sldIdLst>
         </p14:section>
-        <p14:section name="Closing" id="{d740411c-924f-dd6f-b900-874cc49f17f1}">
+        <p14:section name="Closing" id="{819764e5-094d-a55d-7250-18e56bea72a2}">
           <p14:sldIdLst>
             <p14:sldId id="264"/>
           </p14:sldIdLst>
@@ -1180,7 +1180,7 @@
           <a:p>
             <a:r>
               <a:rPr lang="en-US" dirty="0"/>
-              <a:t>Run through each step. The essentials are the menu PDF, opening hours, ResDiary link, and Google account access. Gift cards, What's On content, and photography can follow.</a:t>
+              <a:t>Run through each step. The essentials are the menu PDF, opening hours, ResDiary link, and Google account access. Gift cards and photography can follow. Suggest a What's On page for events and special menus.</a:t>
             </a:r>
             <a:endParaRPr lang="en-US" dirty="0"/>
           </a:p>
@@ -2513,7 +2513,7 @@
                   <a:srgbClr val="062F45"/>
                 </a:solidFill>
               </a:rPr>
-              <a:t>Hard to use on mobile</a:t>
+              <a:t>Frustrating on mobile</a:t>
             </a:r>
             <a:endParaRPr lang="en-US" sz="1600" dirty="0"/>
           </a:p>
@@ -2527,7 +2527,7 @@
                   <a:srgbClr val="3D5A80"/>
                 </a:solidFill>
               </a:rPr>
-              <a:t>Booking and menus exist but the site is so difficult on a phone that customers give up and ring instead</a:t>
+              <a:t>Booking and menus are there but nearly impossible to use on a phone — so customers ring up instead</a:t>
             </a:r>
             <a:endParaRPr lang="en-US" sz="1600" dirty="0"/>
           </a:p>
@@ -4402,7 +4402,7 @@
                   <a:srgbClr val="000000"/>
                 </a:solidFill>
               </a:rPr>
-              <a:t>🎉</a:t>
+              <a:t>🌊</a:t>
             </a:r>
             <a:endParaRPr lang="en-US" sz="1600" dirty="0"/>
           </a:p>
@@ -4438,7 +4438,7 @@
                   <a:srgbClr val="062F45"/>
                 </a:solidFill>
               </a:rPr>
-              <a:t>What's On</a:t>
+              <a:t>Tide Chart</a:t>
             </a:r>
             <a:endParaRPr lang="en-US" sz="1300" dirty="0"/>
           </a:p>
@@ -4452,7 +4452,7 @@
                   <a:srgbClr val="3D5A80"/>
                 </a:solidFill>
               </a:rPr>
-              <a:t>Special menus, themed events, and seasonal weekends — keep visitors in the loop</a:t>
+              <a:t>Live tide times — useful for beachgoers planning a visit</a:t>
             </a:r>
             <a:endParaRPr lang="en-US" sz="1300" dirty="0"/>
           </a:p>
@@ -5728,7 +5728,7 @@
         </p:nvSpPr>
         <p:spPr>
           <a:xfrm>
-            <a:off x="548640" y="1389888"/>
+            <a:off x="548640" y="1344168"/>
             <a:ext cx="320040" cy="320040"/>
           </a:xfrm>
           <a:prstGeom prst="ellipse">
@@ -5748,7 +5748,7 @@
         </p:nvSpPr>
         <p:spPr>
           <a:xfrm>
-            <a:off x="548640" y="1389888"/>
+            <a:off x="548640" y="1344168"/>
             <a:ext cx="320040" cy="320040"/>
           </a:xfrm>
           <a:prstGeom prst="rect">
@@ -5784,7 +5784,7 @@
         </p:nvSpPr>
         <p:spPr>
           <a:xfrm>
-            <a:off x="1005840" y="1371600"/>
+            <a:off x="1005840" y="1325880"/>
             <a:ext cx="7589520" cy="365760"/>
           </a:xfrm>
           <a:prstGeom prst="rect">
@@ -5831,7 +5831,7 @@
         </p:nvSpPr>
         <p:spPr>
           <a:xfrm>
-            <a:off x="731520" y="1737360"/>
+            <a:off x="731520" y="1691640"/>
             <a:ext cx="0" cy="36576"/>
           </a:xfrm>
           <a:prstGeom prst="line">
@@ -5854,7 +5854,7 @@
         </p:nvSpPr>
         <p:spPr>
           <a:xfrm>
-            <a:off x="548640" y="1792224"/>
+            <a:off x="548640" y="1755648"/>
             <a:ext cx="320040" cy="320040"/>
           </a:xfrm>
           <a:prstGeom prst="ellipse">
@@ -5874,7 +5874,7 @@
         </p:nvSpPr>
         <p:spPr>
           <a:xfrm>
-            <a:off x="548640" y="1792224"/>
+            <a:off x="548640" y="1755648"/>
             <a:ext cx="320040" cy="320040"/>
           </a:xfrm>
           <a:prstGeom prst="rect">
@@ -5910,7 +5910,7 @@
         </p:nvSpPr>
         <p:spPr>
           <a:xfrm>
-            <a:off x="1005840" y="1773936"/>
+            <a:off x="1005840" y="1737360"/>
             <a:ext cx="7589520" cy="365760"/>
           </a:xfrm>
           <a:prstGeom prst="rect">
@@ -5957,7 +5957,7 @@
         </p:nvSpPr>
         <p:spPr>
           <a:xfrm>
-            <a:off x="731520" y="2139696"/>
+            <a:off x="731520" y="2103120"/>
             <a:ext cx="0" cy="36576"/>
           </a:xfrm>
           <a:prstGeom prst="line">
@@ -5980,7 +5980,7 @@
         </p:nvSpPr>
         <p:spPr>
           <a:xfrm>
-            <a:off x="548640" y="2194560"/>
+            <a:off x="548640" y="2167128"/>
             <a:ext cx="320040" cy="320040"/>
           </a:xfrm>
           <a:prstGeom prst="ellipse">
@@ -6000,7 +6000,7 @@
         </p:nvSpPr>
         <p:spPr>
           <a:xfrm>
-            <a:off x="548640" y="2194560"/>
+            <a:off x="548640" y="2167128"/>
             <a:ext cx="320040" cy="320040"/>
           </a:xfrm>
           <a:prstGeom prst="rect">
@@ -6036,7 +6036,7 @@
         </p:nvSpPr>
         <p:spPr>
           <a:xfrm>
-            <a:off x="1005840" y="2176272"/>
+            <a:off x="1005840" y="2148840"/>
             <a:ext cx="7589520" cy="365760"/>
           </a:xfrm>
           <a:prstGeom prst="rect">
@@ -6083,7 +6083,7 @@
         </p:nvSpPr>
         <p:spPr>
           <a:xfrm>
-            <a:off x="731520" y="2542032"/>
+            <a:off x="731520" y="2514600"/>
             <a:ext cx="0" cy="36576"/>
           </a:xfrm>
           <a:prstGeom prst="line">
@@ -6106,7 +6106,7 @@
         </p:nvSpPr>
         <p:spPr>
           <a:xfrm>
-            <a:off x="548640" y="2596896"/>
+            <a:off x="548640" y="2578608"/>
             <a:ext cx="320040" cy="320040"/>
           </a:xfrm>
           <a:prstGeom prst="ellipse">
@@ -6126,7 +6126,7 @@
         </p:nvSpPr>
         <p:spPr>
           <a:xfrm>
-            <a:off x="548640" y="2596896"/>
+            <a:off x="548640" y="2578608"/>
             <a:ext cx="320040" cy="320040"/>
           </a:xfrm>
           <a:prstGeom prst="rect">
@@ -6162,7 +6162,7 @@
         </p:nvSpPr>
         <p:spPr>
           <a:xfrm>
-            <a:off x="1005840" y="2578608"/>
+            <a:off x="1005840" y="2560320"/>
             <a:ext cx="7589520" cy="365760"/>
           </a:xfrm>
           <a:prstGeom prst="rect">
@@ -6209,7 +6209,7 @@
         </p:nvSpPr>
         <p:spPr>
           <a:xfrm>
-            <a:off x="731520" y="2944368"/>
+            <a:off x="731520" y="2926080"/>
             <a:ext cx="0" cy="36576"/>
           </a:xfrm>
           <a:prstGeom prst="line">
@@ -6232,7 +6232,7 @@
         </p:nvSpPr>
         <p:spPr>
           <a:xfrm>
-            <a:off x="548640" y="2999232"/>
+            <a:off x="548640" y="2990088"/>
             <a:ext cx="320040" cy="320040"/>
           </a:xfrm>
           <a:prstGeom prst="ellipse">
@@ -6252,7 +6252,7 @@
         </p:nvSpPr>
         <p:spPr>
           <a:xfrm>
-            <a:off x="548640" y="2999232"/>
+            <a:off x="548640" y="2990088"/>
             <a:ext cx="320040" cy="320040"/>
           </a:xfrm>
           <a:prstGeom prst="rect">
@@ -6288,7 +6288,7 @@
         </p:nvSpPr>
         <p:spPr>
           <a:xfrm>
-            <a:off x="1005840" y="2980944"/>
+            <a:off x="1005840" y="2971800"/>
             <a:ext cx="7589520" cy="365760"/>
           </a:xfrm>
           <a:prstGeom prst="rect">
@@ -6335,7 +6335,7 @@
         </p:nvSpPr>
         <p:spPr>
           <a:xfrm>
-            <a:off x="731520" y="3346704"/>
+            <a:off x="731520" y="3337560"/>
             <a:ext cx="0" cy="36576"/>
           </a:xfrm>
           <a:prstGeom prst="line">
@@ -6436,7 +6436,7 @@
                   <a:srgbClr val="062F45"/>
                 </a:solidFill>
               </a:rPr>
-              <a:t>What's On content</a:t>
+              <a:t>Photography (optional)</a:t>
             </a:r>
             <a:pPr indent="0" marL="0">
               <a:buNone/>
@@ -6447,7 +6447,7 @@
                   <a:srgbClr val="3D5A80"/>
                 </a:solidFill>
               </a:rPr>
-              <a:t>  —  Send details of upcoming events, themed nights, or special menus for the new page</a:t>
+              <a:t>  —  Arrange a half-day photo shoot to replace placeholder imagery</a:t>
             </a:r>
             <a:endParaRPr lang="en-US" sz="1300" dirty="0"/>
           </a:p>
@@ -6484,133 +6484,7 @@
         </p:nvSpPr>
         <p:spPr>
           <a:xfrm>
-            <a:off x="548640" y="3803904"/>
-            <a:ext cx="320040" cy="320040"/>
-          </a:xfrm>
-          <a:prstGeom prst="ellipse">
-            <a:avLst/>
-          </a:prstGeom>
-          <a:solidFill>
-            <a:srgbClr val="062F45"/>
-          </a:solidFill>
-          <a:ln/>
-        </p:spPr>
-      </p:sp>
-      <p:sp>
-        <p:nvSpPr>
-          <p:cNvPr id="29" name="Text 27"/>
-          <p:cNvSpPr txBox="1"/>
-          <p:nvPr/>
-        </p:nvSpPr>
-        <p:spPr>
-          <a:xfrm>
-            <a:off x="548640" y="3803904"/>
-            <a:ext cx="320040" cy="320040"/>
-          </a:xfrm>
-          <a:prstGeom prst="rect">
-            <a:avLst/>
-          </a:prstGeom>
-          <a:noFill/>
-          <a:ln/>
-        </p:spPr>
-        <p:txBody>
-          <a:bodyPr wrap="square" lIns="0" tIns="0" rIns="0" bIns="0" rtlCol="0" anchor="ctr"/>
-          <a:lstStyle/>
-          <a:p>
-            <a:pPr algn="ctr" indent="0" marL="0">
-              <a:buNone/>
-            </a:pPr>
-            <a:r>
-              <a:rPr lang="en-US" sz="1200" b="1" dirty="0">
-                <a:solidFill>
-                  <a:srgbClr val="FFFFFF"/>
-                </a:solidFill>
-              </a:rPr>
-              <a:t>7</a:t>
-            </a:r>
-            <a:endParaRPr lang="en-US" sz="1200" dirty="0"/>
-          </a:p>
-        </p:txBody>
-      </p:sp>
-      <p:sp>
-        <p:nvSpPr>
-          <p:cNvPr id="30" name="Text 28"/>
-          <p:cNvSpPr txBox="1"/>
-          <p:nvPr/>
-        </p:nvSpPr>
-        <p:spPr>
-          <a:xfrm>
-            <a:off x="1005840" y="3785616"/>
-            <a:ext cx="7589520" cy="365760"/>
-          </a:xfrm>
-          <a:prstGeom prst="rect">
-            <a:avLst/>
-          </a:prstGeom>
-          <a:noFill/>
-          <a:ln/>
-        </p:spPr>
-        <p:txBody>
-          <a:bodyPr wrap="square" lIns="0" tIns="0" rIns="0" bIns="0" rtlCol="0" anchor="ctr"/>
-          <a:lstStyle/>
-          <a:p>
-            <a:pPr indent="0" marL="0">
-              <a:buNone/>
-            </a:pPr>
-            <a:r>
-              <a:rPr lang="en-US" sz="1300" b="1" dirty="0">
-                <a:solidFill>
-                  <a:srgbClr val="062F45"/>
-                </a:solidFill>
-              </a:rPr>
-              <a:t>Photography (optional)</a:t>
-            </a:r>
-            <a:pPr indent="0" marL="0">
-              <a:buNone/>
-            </a:pPr>
-            <a:r>
-              <a:rPr lang="en-US" sz="1100" dirty="0">
-                <a:solidFill>
-                  <a:srgbClr val="3D5A80"/>
-                </a:solidFill>
-              </a:rPr>
-              <a:t>  —  Arrange a half-day photo shoot to replace placeholder imagery</a:t>
-            </a:r>
-            <a:endParaRPr lang="en-US" sz="1300" dirty="0"/>
-          </a:p>
-        </p:txBody>
-      </p:sp>
-      <p:sp>
-        <p:nvSpPr>
-          <p:cNvPr id="31" name="Shape 29"/>
-          <p:cNvSpPr/>
-          <p:nvPr/>
-        </p:nvSpPr>
-        <p:spPr>
-          <a:xfrm>
-            <a:off x="731520" y="4151376"/>
-            <a:ext cx="0" cy="36576"/>
-          </a:xfrm>
-          <a:prstGeom prst="line">
-            <a:avLst/>
-          </a:prstGeom>
-          <a:noFill/>
-          <a:ln w="19050">
-            <a:solidFill>
-              <a:srgbClr val="C3D0E5"/>
-            </a:solidFill>
-            <a:prstDash val="solid"/>
-          </a:ln>
-        </p:spPr>
-      </p:sp>
-      <p:sp>
-        <p:nvSpPr>
-          <p:cNvPr id="32" name="Shape 30"/>
-          <p:cNvSpPr/>
-          <p:nvPr/>
-        </p:nvSpPr>
-        <p:spPr>
-          <a:xfrm>
-            <a:off x="548640" y="4206240"/>
+            <a:off x="548640" y="3813048"/>
             <a:ext cx="320040" cy="320040"/>
           </a:xfrm>
           <a:prstGeom prst="ellipse">
@@ -6624,13 +6498,13 @@
       </p:sp>
       <p:sp>
         <p:nvSpPr>
-          <p:cNvPr id="33" name="Text 31"/>
-          <p:cNvSpPr txBox="1"/>
-          <p:nvPr/>
-        </p:nvSpPr>
-        <p:spPr>
-          <a:xfrm>
-            <a:off x="548640" y="4206240"/>
+          <p:cNvPr id="29" name="Text 27"/>
+          <p:cNvSpPr txBox="1"/>
+          <p:nvPr/>
+        </p:nvSpPr>
+        <p:spPr>
+          <a:xfrm>
+            <a:off x="548640" y="3813048"/>
             <a:ext cx="320040" cy="320040"/>
           </a:xfrm>
           <a:prstGeom prst="rect">
@@ -6652,7 +6526,7 @@
                   <a:srgbClr val="FFFFFF"/>
                 </a:solidFill>
               </a:rPr>
-              <a:t>8</a:t>
+              <a:t>7</a:t>
             </a:r>
             <a:endParaRPr lang="en-US" sz="1200" dirty="0"/>
           </a:p>
@@ -6660,13 +6534,13 @@
       </p:sp>
       <p:sp>
         <p:nvSpPr>
-          <p:cNvPr id="34" name="Text 32"/>
-          <p:cNvSpPr txBox="1"/>
-          <p:nvPr/>
-        </p:nvSpPr>
-        <p:spPr>
-          <a:xfrm>
-            <a:off x="1005840" y="4187952"/>
+          <p:cNvPr id="30" name="Text 28"/>
+          <p:cNvSpPr txBox="1"/>
+          <p:nvPr/>
+        </p:nvSpPr>
+        <p:spPr>
+          <a:xfrm>
+            <a:off x="1005840" y="3794760"/>
             <a:ext cx="7589520" cy="365760"/>
           </a:xfrm>
           <a:prstGeom prst="rect">
@@ -6702,6 +6576,53 @@
               <a:t>  —  Point your domain to the new site — we handle the technical switch</a:t>
             </a:r>
             <a:endParaRPr lang="en-US" sz="1300" dirty="0"/>
+          </a:p>
+        </p:txBody>
+      </p:sp>
+      <p:sp>
+        <p:nvSpPr>
+          <p:cNvPr id="31" name="Text 29"/>
+          <p:cNvSpPr txBox="1"/>
+          <p:nvPr/>
+        </p:nvSpPr>
+        <p:spPr>
+          <a:xfrm>
+            <a:off x="548640" y="4297680"/>
+            <a:ext cx="8046720" cy="320040"/>
+          </a:xfrm>
+          <a:prstGeom prst="rect">
+            <a:avLst/>
+          </a:prstGeom>
+          <a:noFill/>
+          <a:ln/>
+        </p:spPr>
+        <p:txBody>
+          <a:bodyPr wrap="square" lIns="0" tIns="0" rIns="0" bIns="0" rtlCol="0" anchor="t"/>
+          <a:lstStyle/>
+          <a:p>
+            <a:pPr indent="0" marL="0">
+              <a:buNone/>
+            </a:pPr>
+            <a:r>
+              <a:rPr lang="en-US" sz="1100" b="1" dirty="0">
+                <a:solidFill>
+                  <a:srgbClr val="C8402E"/>
+                </a:solidFill>
+              </a:rPr>
+              <a:t>Suggestion: </a:t>
+            </a:r>
+            <a:pPr indent="0" marL="0">
+              <a:buNone/>
+            </a:pPr>
+            <a:r>
+              <a:rPr lang="en-US" sz="1100" i="1" dirty="0">
+                <a:solidFill>
+                  <a:srgbClr val="3D5A80"/>
+                </a:solidFill>
+              </a:rPr>
+              <a:t>Consider adding a "What's On" page for special menus, themed events, and seasonal weekends — a great way to give customers a reason to keep coming back.</a:t>
+            </a:r>
+            <a:endParaRPr lang="en-US" sz="1100" dirty="0"/>
           </a:p>
         </p:txBody>
       </p:sp>

</xml_diff>

<commit_message>
Add images to pitch deck slides
Sunset/dusk building photo on title and closing slides, old building
photo in the Before column, bay panorama on the photography slide.

Co-Authored-By: Claude Opus 4.6 <noreply@anthropic.com>
Claude-Session: https://claude.ai/code/session_012ZbjzZ7aoL8AUKXKQXjSCU
</commit_message>
<xml_diff>
--- a/SeaShanty_Redesign_Pitch.pptx
+++ b/SeaShanty_Redesign_Pitch.pptx
@@ -115,47 +115,47 @@
   <p:extLst>
     <p:ext uri="{521415D9-36F7-43E2-AB2F-B90AF26B5E84}">
       <p14:sectionLst xmlns:p14="http://schemas.microsoft.com/office/powerpoint/2010/main">
-        <p14:section name="Introduction" id="{636136de-b3c4-2eab-e2a6-0fd5aa7ac792}">
+        <p14:section name="Introduction" id="{628f1d48-c3bd-39c8-dad0-c2fad1a63dc5}">
           <p14:sldIdLst>
             <p14:sldId id="256"/>
           </p14:sldIdLst>
         </p14:section>
-        <p14:section name="The Problem" id="{8386cdb5-af98-fee0-a793-e89ed6acde38}">
+        <p14:section name="The Problem" id="{2dfba2bc-c8b5-888c-bea7-0f9ee7913d57}">
           <p14:sldIdLst>
             <p14:sldId id="257"/>
           </p14:sldIdLst>
         </p14:section>
-        <p14:section name="Before and After" id="{8dd5eb94-2136-4806-e3d6-9091451dc121}">
+        <p14:section name="Before and After" id="{699dac11-b78b-902c-f1ed-3ee7845d8ffe}">
           <p14:sldIdLst>
             <p14:sldId id="258"/>
           </p14:sldIdLst>
         </p14:section>
-        <p14:section name="Why It Matters" id="{0923609d-16b2-2307-7529-ba01cf37ed02}">
+        <p14:section name="Why It Matters" id="{acfe1272-22dc-6b01-5fea-f1686bc7618c}">
           <p14:sldIdLst>
             <p14:sldId id="259"/>
           </p14:sldIdLst>
         </p14:section>
-        <p14:section name="What's Included" id="{e5cefbaf-890d-49c9-60df-f45109d935ba}">
+        <p14:section name="What's Included" id="{99e8a26d-7875-2615-6913-898b57e910f3}">
           <p14:sldIdLst>
             <p14:sldId id="260"/>
           </p14:sldIdLst>
         </p14:section>
-        <p14:section name="Key Features" id="{5ba3bfc9-bf41-f344-a68c-d3af5afc2340}">
+        <p14:section name="Key Features" id="{c7abe92c-588b-a6df-c862-116e34631178}">
           <p14:sldIdLst>
             <p14:sldId id="261"/>
           </p14:sldIdLst>
         </p14:section>
-        <p14:section name="Photography" id="{78a73b39-49a2-fe61-f038-5df8e0971fa3}">
+        <p14:section name="Photography" id="{9484bda4-c485-97aa-8934-a06cab68b361}">
           <p14:sldIdLst>
             <p14:sldId id="262"/>
           </p14:sldIdLst>
         </p14:section>
-        <p14:section name="Next Steps" id="{83190fb4-eef9-7594-8832-3f2aa25344fc}">
+        <p14:section name="Next Steps" id="{36811d23-98f3-25b7-513c-04af21b873f4}">
           <p14:sldIdLst>
             <p14:sldId id="263"/>
           </p14:sldIdLst>
         </p14:section>
-        <p14:section name="Closing" id="{819764e5-094d-a55d-7250-18e56bea72a2}">
+        <p14:section name="Closing" id="{840a1ba5-f8fc-729d-dfea-a04775778e3a}">
           <p14:sldIdLst>
             <p14:sldId id="264"/>
           </p14:sldIdLst>
@@ -2112,16 +2112,47 @@
           <a:chExt cx="0" cy="0"/>
         </a:xfrm>
       </p:grpSpPr>
-      <p:sp>
-        <p:nvSpPr>
-          <p:cNvPr id="2" name="Text 0"/>
+      <p:pic>
+        <p:nvPicPr>
+          <p:cNvPr id="2" name="Image 0" descr="/home/claude/seashantyredesign/assets/images/sea-shanty-dusk.jpg">    </p:cNvPr>
+          <p:cNvPicPr>
+            <a:picLocks noChangeAspect="1"/>
+          </p:cNvPicPr>
+          <p:nvPr/>
+        </p:nvPicPr>
+        <p:blipFill>
+          <a:blip r:embed="rId1"/>
+          <a:stretch>
+            <a:fillRect/>
+          </a:stretch>
+        </p:blipFill>
+        <p:spPr>
+          <a:xfrm>
+            <a:off x="4572000" y="274320"/>
+            <a:ext cx="4297680" cy="3200400"/>
+          </a:xfrm>
+          <a:prstGeom prst="ellipse">
+            <a:avLst/>
+          </a:prstGeom>
+          <a:effectLst>
+            <a:outerShdw sx="100000" sy="100000" kx="0" ky="0" algn="bl" rotWithShape="0" blurRad="101600" dist="38100" dir="8100000">
+              <a:srgbClr val="000000">
+                <a:alpha val="50000"/>
+              </a:srgbClr>
+            </a:outerShdw>
+          </a:effectLst>
+        </p:spPr>
+      </p:pic>
+      <p:sp>
+        <p:nvSpPr>
+          <p:cNvPr id="3" name="Text 0"/>
           <p:cNvSpPr txBox="1"/>
           <p:nvPr/>
         </p:nvSpPr>
         <p:spPr>
           <a:xfrm>
             <a:off x="731520" y="914400"/>
-            <a:ext cx="7680960" cy="2926080"/>
+            <a:ext cx="3657600" cy="2926080"/>
           </a:xfrm>
           <a:prstGeom prst="rect">
             <a:avLst/>
@@ -2184,15 +2215,29 @@
                   <a:srgbClr val="A1B2CE"/>
                 </a:solidFill>
               </a:rPr>
-              <a:t>A modern, mobile-first website for Trearddur Bay's favourite cafe</a:t>
+              <a:t>A modern, mobile-first website for</a:t>
             </a:r>
             <a:endParaRPr lang="en-US" sz="4400" dirty="0"/>
           </a:p>
-        </p:txBody>
-      </p:sp>
-      <p:sp>
-        <p:nvSpPr>
-          <p:cNvPr id="3" name="Text 1"/>
+          <a:p>
+            <a:pPr algn="l" indent="0" marL="0">
+              <a:buNone/>
+            </a:pPr>
+            <a:r>
+              <a:rPr lang="en-US" sz="1400" i="1" dirty="0">
+                <a:solidFill>
+                  <a:srgbClr val="A1B2CE"/>
+                </a:solidFill>
+              </a:rPr>
+              <a:t>Trearddur Bay's favourite cafe</a:t>
+            </a:r>
+            <a:endParaRPr lang="en-US" sz="4400" dirty="0"/>
+          </a:p>
+        </p:txBody>
+      </p:sp>
+      <p:sp>
+        <p:nvSpPr>
+          <p:cNvPr id="4" name="Text 1"/>
           <p:cNvSpPr txBox="1"/>
           <p:nvPr/>
         </p:nvSpPr>
@@ -2242,7 +2287,7 @@
       </p:sp>
       <p:sp>
         <p:nvSpPr>
-          <p:cNvPr id="4" name="Shape 2"/>
+          <p:cNvPr id="5" name="Shape 2"/>
           <p:cNvSpPr/>
           <p:nvPr/>
         </p:nvSpPr>
@@ -2909,12 +2954,19 @@
           </a:p>
         </p:txBody>
       </p:sp>
-      <p:sp>
-        <p:nvSpPr>
-          <p:cNvPr id="5" name="Text 3"/>
-          <p:cNvSpPr txBox="1"/>
-          <p:nvPr/>
-        </p:nvSpPr>
+      <p:pic>
+        <p:nvPicPr>
+          <p:cNvPr id="5" name="Image 0" descr="/home/claude/seashantyredesign/assets/images/old-sea-shanty.jpg">    </p:cNvPr>
+          <p:cNvPicPr>
+            <a:picLocks noChangeAspect="1"/>
+          </p:cNvPicPr>
+          <p:nvPr/>
+        </p:nvPicPr>
+        <p:blipFill>
+          <a:blip r:embed="rId1"/>
+          <a:srcRect l="0" r="0" t="0" b="0"/>
+          <a:stretch/>
+        </p:blipFill>
         <p:spPr>
           <a:xfrm>
             <a:off x="731520" y="1737360"/>
@@ -2923,33 +2975,11 @@
           <a:prstGeom prst="rect">
             <a:avLst/>
           </a:prstGeom>
-          <a:solidFill>
-            <a:srgbClr val="0A3D5C"/>
-          </a:solidFill>
-          <a:ln/>
-        </p:spPr>
-        <p:txBody>
-          <a:bodyPr wrap="square" rtlCol="0" anchor="ctr"/>
-          <a:lstStyle/>
-          <a:p>
-            <a:pPr algn="ctr" indent="0" marL="0">
-              <a:buNone/>
-            </a:pPr>
-            <a:r>
-              <a:rPr lang="en-US" sz="1400" i="1" dirty="0">
-                <a:solidFill>
-                  <a:srgbClr val="A1B2CE"/>
-                </a:solidFill>
-              </a:rPr>
-              <a:t>Screenshot placeholder</a:t>
-            </a:r>
-            <a:endParaRPr lang="en-US" sz="1400" dirty="0"/>
-          </a:p>
-        </p:txBody>
-      </p:sp>
-      <p:sp>
-        <p:nvSpPr>
-          <p:cNvPr id="6" name="Shape 4"/>
+        </p:spPr>
+      </p:pic>
+      <p:sp>
+        <p:nvSpPr>
+          <p:cNvPr id="6" name="Shape 3"/>
           <p:cNvSpPr/>
           <p:nvPr/>
         </p:nvSpPr>
@@ -2971,7 +3001,7 @@
       </p:sp>
       <p:sp>
         <p:nvSpPr>
-          <p:cNvPr id="7" name="Text 5"/>
+          <p:cNvPr id="7" name="Text 4"/>
           <p:cNvSpPr txBox="1"/>
           <p:nvPr/>
         </p:nvSpPr>
@@ -3007,7 +3037,7 @@
       </p:sp>
       <p:sp>
         <p:nvSpPr>
-          <p:cNvPr id="8" name="Text 6"/>
+          <p:cNvPr id="8" name="Text 5"/>
           <p:cNvSpPr txBox="1"/>
           <p:nvPr/>
         </p:nvSpPr>
@@ -3045,7 +3075,7 @@
       </p:sp>
       <p:sp>
         <p:nvSpPr>
-          <p:cNvPr id="9" name="Text 7"/>
+          <p:cNvPr id="9" name="Text 6"/>
           <p:cNvSpPr txBox="1"/>
           <p:nvPr/>
         </p:nvSpPr>
@@ -5531,9 +5561,39 @@
           </a:p>
         </p:txBody>
       </p:sp>
-      <p:sp>
-        <p:nvSpPr>
-          <p:cNvPr id="7" name="Text 5"/>
+      <p:pic>
+        <p:nvPicPr>
+          <p:cNvPr id="7" name="Image 0" descr="/home/claude/seashantyredesign/assets/images/trearddur-bay.jpg">    </p:cNvPr>
+          <p:cNvPicPr>
+            <a:picLocks noChangeAspect="1"/>
+          </p:cNvPicPr>
+          <p:nvPr/>
+        </p:nvPicPr>
+        <p:blipFill>
+          <a:blip r:embed="rId1"/>
+          <a:srcRect l="0" r="0" t="0" b="0"/>
+          <a:stretch/>
+        </p:blipFill>
+        <p:spPr>
+          <a:xfrm>
+            <a:off x="5669280" y="1051560"/>
+            <a:ext cx="2926080" cy="1371600"/>
+          </a:xfrm>
+          <a:prstGeom prst="ellipse">
+            <a:avLst/>
+          </a:prstGeom>
+          <a:effectLst>
+            <a:outerShdw sx="100000" sy="100000" kx="0" ky="0" algn="bl" rotWithShape="0" blurRad="63500" dist="25400" dir="8100000">
+              <a:srgbClr val="CCCCCC">
+                <a:alpha val="30000"/>
+              </a:srgbClr>
+            </a:outerShdw>
+          </a:effectLst>
+        </p:spPr>
+      </p:pic>
+      <p:sp>
+        <p:nvSpPr>
+          <p:cNvPr id="8" name="Text 5"/>
           <p:cNvSpPr txBox="1"/>
           <p:nvPr/>
         </p:nvSpPr>
@@ -6696,9 +6756,40 @@
           <a:chExt cx="0" cy="0"/>
         </a:xfrm>
       </p:grpSpPr>
-      <p:sp>
-        <p:nvSpPr>
-          <p:cNvPr id="2" name="Shape 0"/>
+      <p:pic>
+        <p:nvPicPr>
+          <p:cNvPr id="2" name="Image 0" descr="/home/claude/seashantyredesign/assets/images/sea-shanty-dusk.jpg">    </p:cNvPr>
+          <p:cNvPicPr>
+            <a:picLocks noChangeAspect="1"/>
+          </p:cNvPicPr>
+          <p:nvPr/>
+        </p:nvPicPr>
+        <p:blipFill>
+          <a:blip r:embed="rId1"/>
+          <a:stretch>
+            <a:fillRect/>
+          </a:stretch>
+        </p:blipFill>
+        <p:spPr>
+          <a:xfrm>
+            <a:off x="4754880" y="548640"/>
+            <a:ext cx="4114800" cy="3017520"/>
+          </a:xfrm>
+          <a:prstGeom prst="ellipse">
+            <a:avLst/>
+          </a:prstGeom>
+          <a:effectLst>
+            <a:outerShdw sx="100000" sy="100000" kx="0" ky="0" algn="bl" rotWithShape="0" blurRad="101600" dist="38100" dir="8100000">
+              <a:srgbClr val="000000">
+                <a:alpha val="50000"/>
+              </a:srgbClr>
+            </a:outerShdw>
+          </a:effectLst>
+        </p:spPr>
+      </p:pic>
+      <p:sp>
+        <p:nvSpPr>
+          <p:cNvPr id="3" name="Shape 0"/>
           <p:cNvSpPr/>
           <p:nvPr/>
         </p:nvSpPr>
@@ -6718,14 +6809,14 @@
       </p:sp>
       <p:sp>
         <p:nvSpPr>
-          <p:cNvPr id="3" name="Text 1"/>
+          <p:cNvPr id="4" name="Text 1"/>
           <p:cNvSpPr txBox="1"/>
           <p:nvPr/>
         </p:nvSpPr>
         <p:spPr>
           <a:xfrm>
             <a:off x="731520" y="1828800"/>
-            <a:ext cx="7680960" cy="2560320"/>
+            <a:ext cx="3840480" cy="2560320"/>
           </a:xfrm>
           <a:prstGeom prst="rect">
             <a:avLst/>
@@ -6774,7 +6865,7 @@
                   <a:srgbClr val="C3D0E5"/>
                 </a:solidFill>
               </a:rPr>
-              <a:t>The new Sea Shanty website is built, mobile-optimised,</a:t>
+              <a:t>The new Sea Shanty website is</a:t>
             </a:r>
             <a:endParaRPr lang="en-US" sz="3800" dirty="0"/>
           </a:p>
@@ -6788,7 +6879,21 @@
                   <a:srgbClr val="C3D0E5"/>
                 </a:solidFill>
               </a:rPr>
-              <a:t>and waiting to go live.</a:t>
+              <a:t>built, mobile-optimised, and</a:t>
+            </a:r>
+            <a:endParaRPr lang="en-US" sz="3800" dirty="0"/>
+          </a:p>
+          <a:p>
+            <a:pPr indent="0" marL="0">
+              <a:buNone/>
+            </a:pPr>
+            <a:r>
+              <a:rPr lang="en-US" sz="1600" dirty="0">
+                <a:solidFill>
+                  <a:srgbClr val="C3D0E5"/>
+                </a:solidFill>
+              </a:rPr>
+              <a:t>waiting to go live.</a:t>
             </a:r>
             <a:endParaRPr lang="en-US" sz="3800" dirty="0"/>
           </a:p>

</xml_diff>

<commit_message>
Fix title slide strikethrough and revert slide 3 to website placeholders
Move red accent line below tagline text to prevent overlap, and replace
old building photo on Before & After slide with screenshot placeholder.

Co-Authored-By: Claude Opus 4.6 <noreply@anthropic.com>
Claude-Session: https://claude.ai/code/session_012ZbjzZ7aoL8AUKXKQXjSCU
</commit_message>
<xml_diff>
--- a/SeaShanty_Redesign_Pitch.pptx
+++ b/SeaShanty_Redesign_Pitch.pptx
@@ -115,47 +115,47 @@
   <p:extLst>
     <p:ext uri="{521415D9-36F7-43E2-AB2F-B90AF26B5E84}">
       <p14:sectionLst xmlns:p14="http://schemas.microsoft.com/office/powerpoint/2010/main">
-        <p14:section name="Introduction" id="{628f1d48-c3bd-39c8-dad0-c2fad1a63dc5}">
+        <p14:section name="Introduction" id="{14d7fb5d-8f63-0981-bab5-7d0b2029d5de}">
           <p14:sldIdLst>
             <p14:sldId id="256"/>
           </p14:sldIdLst>
         </p14:section>
-        <p14:section name="The Problem" id="{2dfba2bc-c8b5-888c-bea7-0f9ee7913d57}">
+        <p14:section name="The Problem" id="{c85063d4-5d98-b85a-6590-02f23cc3b542}">
           <p14:sldIdLst>
             <p14:sldId id="257"/>
           </p14:sldIdLst>
         </p14:section>
-        <p14:section name="Before and After" id="{699dac11-b78b-902c-f1ed-3ee7845d8ffe}">
+        <p14:section name="Before and After" id="{53860867-05ff-adf6-0082-eb8b4e8533af}">
           <p14:sldIdLst>
             <p14:sldId id="258"/>
           </p14:sldIdLst>
         </p14:section>
-        <p14:section name="Why It Matters" id="{acfe1272-22dc-6b01-5fea-f1686bc7618c}">
+        <p14:section name="Why It Matters" id="{85cd6f5d-d7e0-2145-2c57-4815fd94e5ba}">
           <p14:sldIdLst>
             <p14:sldId id="259"/>
           </p14:sldIdLst>
         </p14:section>
-        <p14:section name="What's Included" id="{99e8a26d-7875-2615-6913-898b57e910f3}">
+        <p14:section name="What's Included" id="{d32cf80d-2188-8285-83e2-3c481930e865}">
           <p14:sldIdLst>
             <p14:sldId id="260"/>
           </p14:sldIdLst>
         </p14:section>
-        <p14:section name="Key Features" id="{c7abe92c-588b-a6df-c862-116e34631178}">
+        <p14:section name="Key Features" id="{e2b6f5dc-5487-1e14-8a6b-8dde3bc26c36}">
           <p14:sldIdLst>
             <p14:sldId id="261"/>
           </p14:sldIdLst>
         </p14:section>
-        <p14:section name="Photography" id="{9484bda4-c485-97aa-8934-a06cab68b361}">
+        <p14:section name="Photography" id="{199d6632-89ae-a377-31d3-6c40a39a02eb}">
           <p14:sldIdLst>
             <p14:sldId id="262"/>
           </p14:sldIdLst>
         </p14:section>
-        <p14:section name="Next Steps" id="{36811d23-98f3-25b7-513c-04af21b873f4}">
+        <p14:section name="Next Steps" id="{d403a2ce-327d-ad84-6f99-895519103020}">
           <p14:sldIdLst>
             <p14:sldId id="263"/>
           </p14:sldIdLst>
         </p14:section>
-        <p14:section name="Closing" id="{840a1ba5-f8fc-729d-dfea-a04775778e3a}">
+        <p14:section name="Closing" id="{db77be5e-1b03-060e-bef5-7a63eae45a97}">
           <p14:sldIdLst>
             <p14:sldId id="264"/>
           </p14:sldIdLst>
@@ -2152,7 +2152,7 @@
         <p:spPr>
           <a:xfrm>
             <a:off x="731520" y="914400"/>
-            <a:ext cx="3657600" cy="2926080"/>
+            <a:ext cx="3657600" cy="2377440"/>
           </a:xfrm>
           <a:prstGeom prst="rect">
             <a:avLst/>
@@ -2196,7 +2196,7 @@
               <a:buNone/>
             </a:pPr>
             <a:r>
-              <a:rPr lang="en-US" sz="1400" dirty="0">
+              <a:rPr lang="en-US" sz="1000" dirty="0">
                 <a:solidFill>
                   <a:srgbClr val="000000"/>
                 </a:solidFill>
@@ -2237,63 +2237,13 @@
       </p:sp>
       <p:sp>
         <p:nvSpPr>
-          <p:cNvPr id="4" name="Text 1"/>
-          <p:cNvSpPr txBox="1"/>
-          <p:nvPr/>
-        </p:nvSpPr>
-        <p:spPr>
-          <a:xfrm>
-            <a:off x="731520" y="3474720"/>
-            <a:ext cx="3657600" cy="640080"/>
-          </a:xfrm>
-          <a:prstGeom prst="rect">
-            <a:avLst/>
-          </a:prstGeom>
-          <a:noFill/>
-          <a:ln/>
-        </p:spPr>
-        <p:txBody>
-          <a:bodyPr wrap="square" lIns="0" tIns="0" rIns="0" bIns="0" rtlCol="0" anchor="ctr"/>
-          <a:lstStyle/>
-          <a:p>
-            <a:pPr indent="0" marL="0">
-              <a:buNone/>
-            </a:pPr>
-            <a:r>
-              <a:rPr lang="en-US" sz="1300" dirty="0">
-                <a:solidFill>
-                  <a:srgbClr val="C3D0E5"/>
-                </a:solidFill>
-              </a:rPr>
-              <a:t>Prepared by Max Walsh</a:t>
-            </a:r>
-            <a:endParaRPr lang="en-US" sz="1300" dirty="0"/>
-          </a:p>
-          <a:p>
-            <a:pPr indent="0" marL="0">
-              <a:buNone/>
-            </a:pPr>
-            <a:r>
-              <a:rPr lang="en-US" sz="1200" dirty="0">
-                <a:solidFill>
-                  <a:srgbClr val="A1B2CE"/>
-                </a:solidFill>
-              </a:rPr>
-              <a:t>October 2026</a:t>
-            </a:r>
-            <a:endParaRPr lang="en-US" sz="1300" dirty="0"/>
-          </a:p>
-        </p:txBody>
-      </p:sp>
-      <p:sp>
-        <p:nvSpPr>
-          <p:cNvPr id="5" name="Shape 2"/>
+          <p:cNvPr id="4" name="Shape 1"/>
           <p:cNvSpPr/>
           <p:nvPr/>
         </p:nvSpPr>
         <p:spPr>
           <a:xfrm>
-            <a:off x="731520" y="3246120"/>
+            <a:off x="731520" y="3337560"/>
             <a:ext cx="2286000" cy="27432"/>
           </a:xfrm>
           <a:prstGeom prst="rect">
@@ -2304,6 +2254,56 @@
           </a:solidFill>
           <a:ln/>
         </p:spPr>
+      </p:sp>
+      <p:sp>
+        <p:nvSpPr>
+          <p:cNvPr id="5" name="Text 2"/>
+          <p:cNvSpPr txBox="1"/>
+          <p:nvPr/>
+        </p:nvSpPr>
+        <p:spPr>
+          <a:xfrm>
+            <a:off x="731520" y="3520440"/>
+            <a:ext cx="3657600" cy="548640"/>
+          </a:xfrm>
+          <a:prstGeom prst="rect">
+            <a:avLst/>
+          </a:prstGeom>
+          <a:noFill/>
+          <a:ln/>
+        </p:spPr>
+        <p:txBody>
+          <a:bodyPr wrap="square" lIns="0" tIns="0" rIns="0" bIns="0" rtlCol="0" anchor="ctr"/>
+          <a:lstStyle/>
+          <a:p>
+            <a:pPr indent="0" marL="0">
+              <a:buNone/>
+            </a:pPr>
+            <a:r>
+              <a:rPr lang="en-US" sz="1300" dirty="0">
+                <a:solidFill>
+                  <a:srgbClr val="C3D0E5"/>
+                </a:solidFill>
+              </a:rPr>
+              <a:t>Prepared by Max Walsh</a:t>
+            </a:r>
+            <a:endParaRPr lang="en-US" sz="1300" dirty="0"/>
+          </a:p>
+          <a:p>
+            <a:pPr indent="0" marL="0">
+              <a:buNone/>
+            </a:pPr>
+            <a:r>
+              <a:rPr lang="en-US" sz="1200" dirty="0">
+                <a:solidFill>
+                  <a:srgbClr val="A1B2CE"/>
+                </a:solidFill>
+              </a:rPr>
+              <a:t>October 2026</a:t>
+            </a:r>
+            <a:endParaRPr lang="en-US" sz="1300" dirty="0"/>
+          </a:p>
+        </p:txBody>
       </p:sp>
     </p:spTree>
   </p:cSld>
@@ -2954,19 +2954,12 @@
           </a:p>
         </p:txBody>
       </p:sp>
-      <p:pic>
-        <p:nvPicPr>
-          <p:cNvPr id="5" name="Image 0" descr="/home/claude/seashantyredesign/assets/images/old-sea-shanty.jpg">    </p:cNvPr>
-          <p:cNvPicPr>
-            <a:picLocks noChangeAspect="1"/>
-          </p:cNvPicPr>
-          <p:nvPr/>
-        </p:nvPicPr>
-        <p:blipFill>
-          <a:blip r:embed="rId1"/>
-          <a:srcRect l="0" r="0" t="0" b="0"/>
-          <a:stretch/>
-        </p:blipFill>
+      <p:sp>
+        <p:nvSpPr>
+          <p:cNvPr id="5" name="Text 3"/>
+          <p:cNvSpPr txBox="1"/>
+          <p:nvPr/>
+        </p:nvSpPr>
         <p:spPr>
           <a:xfrm>
             <a:off x="731520" y="1737360"/>
@@ -2975,11 +2968,33 @@
           <a:prstGeom prst="rect">
             <a:avLst/>
           </a:prstGeom>
-        </p:spPr>
-      </p:pic>
-      <p:sp>
-        <p:nvSpPr>
-          <p:cNvPr id="6" name="Shape 3"/>
+          <a:solidFill>
+            <a:srgbClr val="0A3D5C"/>
+          </a:solidFill>
+          <a:ln/>
+        </p:spPr>
+        <p:txBody>
+          <a:bodyPr wrap="square" rtlCol="0" anchor="ctr"/>
+          <a:lstStyle/>
+          <a:p>
+            <a:pPr algn="ctr" indent="0" marL="0">
+              <a:buNone/>
+            </a:pPr>
+            <a:r>
+              <a:rPr lang="en-US" sz="1400" i="1" dirty="0">
+                <a:solidFill>
+                  <a:srgbClr val="A1B2CE"/>
+                </a:solidFill>
+              </a:rPr>
+              <a:t>Screenshot placeholder</a:t>
+            </a:r>
+            <a:endParaRPr lang="en-US" sz="1400" dirty="0"/>
+          </a:p>
+        </p:txBody>
+      </p:sp>
+      <p:sp>
+        <p:nvSpPr>
+          <p:cNvPr id="6" name="Shape 4"/>
           <p:cNvSpPr/>
           <p:nvPr/>
         </p:nvSpPr>
@@ -3001,7 +3016,7 @@
       </p:sp>
       <p:sp>
         <p:nvSpPr>
-          <p:cNvPr id="7" name="Text 4"/>
+          <p:cNvPr id="7" name="Text 5"/>
           <p:cNvSpPr txBox="1"/>
           <p:nvPr/>
         </p:nvSpPr>
@@ -3037,7 +3052,7 @@
       </p:sp>
       <p:sp>
         <p:nvSpPr>
-          <p:cNvPr id="8" name="Text 5"/>
+          <p:cNvPr id="8" name="Text 6"/>
           <p:cNvSpPr txBox="1"/>
           <p:nvPr/>
         </p:nvSpPr>
@@ -3075,7 +3090,7 @@
       </p:sp>
       <p:sp>
         <p:nvSpPr>
-          <p:cNvPr id="9" name="Text 6"/>
+          <p:cNvPr id="9" name="Text 7"/>
           <p:cNvSpPr txBox="1"/>
           <p:nvPr/>
         </p:nvSpPr>

</xml_diff>

<commit_message>
Replace Smart Navigation with FAQ on Key Features slide and fix closing slide alignment
Co-Authored-By: Claude Opus 4.6 <noreply@anthropic.com>
Claude-Session: https://claude.ai/code/session_012ZbjzZ7aoL8AUKXKQXjSCU
</commit_message>
<xml_diff>
--- a/SeaShanty_Redesign_Pitch.pptx
+++ b/SeaShanty_Redesign_Pitch.pptx
@@ -115,47 +115,47 @@
   <p:extLst>
     <p:ext uri="{521415D9-36F7-43E2-AB2F-B90AF26B5E84}">
       <p14:sectionLst xmlns:p14="http://schemas.microsoft.com/office/powerpoint/2010/main">
-        <p14:section name="Introduction" id="{14d7fb5d-8f63-0981-bab5-7d0b2029d5de}">
+        <p14:section name="Introduction" id="{de810f16-0374-c91e-4d11-ce3cf6f10fba}">
           <p14:sldIdLst>
             <p14:sldId id="256"/>
           </p14:sldIdLst>
         </p14:section>
-        <p14:section name="The Problem" id="{c85063d4-5d98-b85a-6590-02f23cc3b542}">
+        <p14:section name="The Problem" id="{0a2ba406-d920-d626-5d32-c064cd8a62ce}">
           <p14:sldIdLst>
             <p14:sldId id="257"/>
           </p14:sldIdLst>
         </p14:section>
-        <p14:section name="Before and After" id="{53860867-05ff-adf6-0082-eb8b4e8533af}">
+        <p14:section name="Before and After" id="{3b88e7bb-0d46-14d6-d1eb-461e2df4c084}">
           <p14:sldIdLst>
             <p14:sldId id="258"/>
           </p14:sldIdLst>
         </p14:section>
-        <p14:section name="Why It Matters" id="{85cd6f5d-d7e0-2145-2c57-4815fd94e5ba}">
+        <p14:section name="Why It Matters" id="{28d4916c-976c-268d-c5d3-df54a440f4a9}">
           <p14:sldIdLst>
             <p14:sldId id="259"/>
           </p14:sldIdLst>
         </p14:section>
-        <p14:section name="What's Included" id="{d32cf80d-2188-8285-83e2-3c481930e865}">
+        <p14:section name="What's Included" id="{cafa4852-2ee4-c71f-4bbf-1764599ddf93}">
           <p14:sldIdLst>
             <p14:sldId id="260"/>
           </p14:sldIdLst>
         </p14:section>
-        <p14:section name="Key Features" id="{e2b6f5dc-5487-1e14-8a6b-8dde3bc26c36}">
+        <p14:section name="Key Features" id="{c15d2c41-4685-59e1-c83c-44257346b15b}">
           <p14:sldIdLst>
             <p14:sldId id="261"/>
           </p14:sldIdLst>
         </p14:section>
-        <p14:section name="Photography" id="{199d6632-89ae-a377-31d3-6c40a39a02eb}">
+        <p14:section name="Photography" id="{af24ffca-a15c-b4a7-2947-73346724a792}">
           <p14:sldIdLst>
             <p14:sldId id="262"/>
           </p14:sldIdLst>
         </p14:section>
-        <p14:section name="Next Steps" id="{d403a2ce-327d-ad84-6f99-895519103020}">
+        <p14:section name="Next Steps" id="{2f032e5e-c5d8-7f30-4d66-e834e0649c05}">
           <p14:sldIdLst>
             <p14:sldId id="263"/>
           </p14:sldIdLst>
         </p14:section>
-        <p14:section name="Closing" id="{db77be5e-1b03-060e-bef5-7a63eae45a97}">
+        <p14:section name="Closing" id="{8e3d0c95-edf3-9557-85bd-29f7b3045f2d}">
           <p14:sldIdLst>
             <p14:sldId id="264"/>
           </p14:sldIdLst>
@@ -5190,7 +5190,7 @@
                   <a:srgbClr val="FFFFFF"/>
                 </a:solidFill>
               </a:rPr>
-              <a:t>Smart Navigation</a:t>
+              <a:t>FAQ Page</a:t>
             </a:r>
             <a:endParaRPr lang="en-US" sz="1800" dirty="0"/>
           </a:p>
@@ -5226,7 +5226,7 @@
                   <a:srgbClr val="A1B2CE"/>
                 </a:solidFill>
               </a:rPr>
-              <a:t>Sticky header, mobile hamburger menu, smooth scroll-to-section — visitors find what they need without hunting</a:t>
+              <a:t>Dogs, parking, groups, allergens — all answered on one page. Fewer calls about the basics means more time for your customers</a:t>
             </a:r>
             <a:endParaRPr lang="en-US" sz="1200" dirty="0"/>
           </a:p>
@@ -6804,13 +6804,49 @@
       </p:pic>
       <p:sp>
         <p:nvSpPr>
-          <p:cNvPr id="3" name="Shape 0"/>
+          <p:cNvPr id="3" name="Text 0"/>
+          <p:cNvSpPr txBox="1"/>
+          <p:nvPr/>
+        </p:nvSpPr>
+        <p:spPr>
+          <a:xfrm>
+            <a:off x="731520" y="731520"/>
+            <a:ext cx="3840480" cy="1005840"/>
+          </a:xfrm>
+          <a:prstGeom prst="rect">
+            <a:avLst/>
+          </a:prstGeom>
+          <a:noFill/>
+          <a:ln/>
+        </p:spPr>
+        <p:txBody>
+          <a:bodyPr wrap="square" lIns="0" tIns="0" rIns="0" bIns="0" rtlCol="0" anchor="ctr"/>
+          <a:lstStyle/>
+          <a:p>
+            <a:pPr indent="0" marL="0">
+              <a:buNone/>
+            </a:pPr>
+            <a:r>
+              <a:rPr lang="en-US" sz="3800" b="1" dirty="0">
+                <a:solidFill>
+                  <a:srgbClr val="FFFFFF"/>
+                </a:solidFill>
+              </a:rPr>
+              <a:t>Ready when you are.</a:t>
+            </a:r>
+            <a:endParaRPr lang="en-US" sz="3800" dirty="0"/>
+          </a:p>
+        </p:txBody>
+      </p:sp>
+      <p:sp>
+        <p:nvSpPr>
+          <p:cNvPr id="4" name="Shape 1"/>
           <p:cNvSpPr/>
           <p:nvPr/>
         </p:nvSpPr>
         <p:spPr>
           <a:xfrm>
-            <a:off x="731520" y="1645920"/>
+            <a:off x="731520" y="1783080"/>
             <a:ext cx="2286000" cy="27432"/>
           </a:xfrm>
           <a:prstGeom prst="rect">
@@ -6824,14 +6860,14 @@
       </p:sp>
       <p:sp>
         <p:nvSpPr>
-          <p:cNvPr id="4" name="Text 1"/>
-          <p:cNvSpPr txBox="1"/>
-          <p:nvPr/>
-        </p:nvSpPr>
-        <p:spPr>
-          <a:xfrm>
-            <a:off x="731520" y="1828800"/>
-            <a:ext cx="3840480" cy="2560320"/>
+          <p:cNvPr id="5" name="Text 2"/>
+          <p:cNvSpPr txBox="1"/>
+          <p:nvPr/>
+        </p:nvSpPr>
+        <p:spPr>
+          <a:xfrm>
+            <a:off x="731520" y="1965960"/>
+            <a:ext cx="3840480" cy="1828800"/>
           </a:xfrm>
           <a:prstGeom prst="rect">
             <a:avLst/>
@@ -6847,14 +6883,42 @@
               <a:buNone/>
             </a:pPr>
             <a:r>
-              <a:rPr lang="en-US" sz="3800" b="1" dirty="0">
-                <a:solidFill>
-                  <a:srgbClr val="FFFFFF"/>
-                </a:solidFill>
-              </a:rPr>
-              <a:t>Ready when you are.</a:t>
-            </a:r>
-            <a:endParaRPr lang="en-US" sz="3800" dirty="0"/>
+              <a:rPr lang="en-US" sz="1600" dirty="0">
+                <a:solidFill>
+                  <a:srgbClr val="C3D0E5"/>
+                </a:solidFill>
+              </a:rPr>
+              <a:t>The new Sea Shanty website is built,</a:t>
+            </a:r>
+            <a:endParaRPr lang="en-US" sz="1600" dirty="0"/>
+          </a:p>
+          <a:p>
+            <a:pPr indent="0" marL="0">
+              <a:buNone/>
+            </a:pPr>
+            <a:r>
+              <a:rPr lang="en-US" sz="1600" dirty="0">
+                <a:solidFill>
+                  <a:srgbClr val="C3D0E5"/>
+                </a:solidFill>
+              </a:rPr>
+              <a:t>mobile-optimised, and waiting to go live.</a:t>
+            </a:r>
+            <a:endParaRPr lang="en-US" sz="1600" dirty="0"/>
+          </a:p>
+          <a:p>
+            <a:pPr indent="0" marL="0">
+              <a:buNone/>
+            </a:pPr>
+            <a:r>
+              <a:rPr lang="en-US" sz="1200" dirty="0">
+                <a:solidFill>
+                  <a:srgbClr val="000000"/>
+                </a:solidFill>
+              </a:rPr>
+              <a:t> </a:t>
+            </a:r>
+            <a:endParaRPr lang="en-US" sz="1600" dirty="0"/>
           </a:p>
           <a:p>
             <a:pPr indent="0" marL="0">
@@ -6863,82 +6927,12 @@
             <a:r>
               <a:rPr lang="en-US" sz="1400" dirty="0">
                 <a:solidFill>
-                  <a:srgbClr val="000000"/>
-                </a:solidFill>
-              </a:rPr>
-              <a:t> </a:t>
-            </a:r>
-            <a:endParaRPr lang="en-US" sz="3800" dirty="0"/>
-          </a:p>
-          <a:p>
-            <a:pPr indent="0" marL="0">
-              <a:buNone/>
-            </a:pPr>
-            <a:r>
-              <a:rPr lang="en-US" sz="1600" dirty="0">
-                <a:solidFill>
-                  <a:srgbClr val="C3D0E5"/>
-                </a:solidFill>
-              </a:rPr>
-              <a:t>The new Sea Shanty website is</a:t>
-            </a:r>
-            <a:endParaRPr lang="en-US" sz="3800" dirty="0"/>
-          </a:p>
-          <a:p>
-            <a:pPr indent="0" marL="0">
-              <a:buNone/>
-            </a:pPr>
-            <a:r>
-              <a:rPr lang="en-US" sz="1600" dirty="0">
-                <a:solidFill>
-                  <a:srgbClr val="C3D0E5"/>
-                </a:solidFill>
-              </a:rPr>
-              <a:t>built, mobile-optimised, and</a:t>
-            </a:r>
-            <a:endParaRPr lang="en-US" sz="3800" dirty="0"/>
-          </a:p>
-          <a:p>
-            <a:pPr indent="0" marL="0">
-              <a:buNone/>
-            </a:pPr>
-            <a:r>
-              <a:rPr lang="en-US" sz="1600" dirty="0">
-                <a:solidFill>
-                  <a:srgbClr val="C3D0E5"/>
-                </a:solidFill>
-              </a:rPr>
-              <a:t>waiting to go live.</a:t>
-            </a:r>
-            <a:endParaRPr lang="en-US" sz="3800" dirty="0"/>
-          </a:p>
-          <a:p>
-            <a:pPr indent="0" marL="0">
-              <a:buNone/>
-            </a:pPr>
-            <a:r>
-              <a:rPr lang="en-US" sz="1400" dirty="0">
-                <a:solidFill>
-                  <a:srgbClr val="000000"/>
-                </a:solidFill>
-              </a:rPr>
-              <a:t> </a:t>
-            </a:r>
-            <a:endParaRPr lang="en-US" sz="3800" dirty="0"/>
-          </a:p>
-          <a:p>
-            <a:pPr indent="0" marL="0">
-              <a:buNone/>
-            </a:pPr>
-            <a:r>
-              <a:rPr lang="en-US" sz="1400" dirty="0">
-                <a:solidFill>
                   <a:srgbClr val="A1B2CE"/>
                 </a:solidFill>
               </a:rPr>
               <a:t>Max Walsh</a:t>
             </a:r>
-            <a:endParaRPr lang="en-US" sz="3800" dirty="0"/>
+            <a:endParaRPr lang="en-US" sz="1600" dirty="0"/>
           </a:p>
           <a:p>
             <a:pPr indent="0" marL="0">
@@ -6952,7 +6946,7 @@
               </a:rPr>
               <a:t>maxwalsh0@gmail.com</a:t>
             </a:r>
-            <a:endParaRPr lang="en-US" sz="3800" dirty="0"/>
+            <a:endParaRPr lang="en-US" sz="1600" dirty="0"/>
           </a:p>
         </p:txBody>
       </p:sp>

</xml_diff>

<commit_message>
Add Smart Navigation and FAQ as four-card Key Features slide
Co-Authored-By: Claude Opus 4.6 <noreply@anthropic.com>
Claude-Session: https://claude.ai/code/session_012ZbjzZ7aoL8AUKXKQXjSCU
</commit_message>
<xml_diff>
--- a/SeaShanty_Redesign_Pitch.pptx
+++ b/SeaShanty_Redesign_Pitch.pptx
@@ -115,47 +115,47 @@
   <p:extLst>
     <p:ext uri="{521415D9-36F7-43E2-AB2F-B90AF26B5E84}">
       <p14:sectionLst xmlns:p14="http://schemas.microsoft.com/office/powerpoint/2010/main">
-        <p14:section name="Introduction" id="{de810f16-0374-c91e-4d11-ce3cf6f10fba}">
+        <p14:section name="Introduction" id="{1d7e79f3-8d83-8b71-4b5c-31b9e54a91d3}">
           <p14:sldIdLst>
             <p14:sldId id="256"/>
           </p14:sldIdLst>
         </p14:section>
-        <p14:section name="The Problem" id="{0a2ba406-d920-d626-5d32-c064cd8a62ce}">
+        <p14:section name="The Problem" id="{50ecd757-35ae-e48f-e99c-3c63a5957a2c}">
           <p14:sldIdLst>
             <p14:sldId id="257"/>
           </p14:sldIdLst>
         </p14:section>
-        <p14:section name="Before and After" id="{3b88e7bb-0d46-14d6-d1eb-461e2df4c084}">
+        <p14:section name="Before and After" id="{4bcc15e9-8b1a-55be-2b63-774e890aaa7e}">
           <p14:sldIdLst>
             <p14:sldId id="258"/>
           </p14:sldIdLst>
         </p14:section>
-        <p14:section name="Why It Matters" id="{28d4916c-976c-268d-c5d3-df54a440f4a9}">
+        <p14:section name="Why It Matters" id="{4030c79f-7fe8-6a17-dacc-b74a80c9490b}">
           <p14:sldIdLst>
             <p14:sldId id="259"/>
           </p14:sldIdLst>
         </p14:section>
-        <p14:section name="What's Included" id="{cafa4852-2ee4-c71f-4bbf-1764599ddf93}">
+        <p14:section name="What's Included" id="{4b1e712b-0698-73a4-ab63-5ea24ea21a68}">
           <p14:sldIdLst>
             <p14:sldId id="260"/>
           </p14:sldIdLst>
         </p14:section>
-        <p14:section name="Key Features" id="{c15d2c41-4685-59e1-c83c-44257346b15b}">
+        <p14:section name="Key Features" id="{a47b80c9-d777-ff0a-45da-a9f6de0a198f}">
           <p14:sldIdLst>
             <p14:sldId id="261"/>
           </p14:sldIdLst>
         </p14:section>
-        <p14:section name="Photography" id="{af24ffca-a15c-b4a7-2947-73346724a792}">
+        <p14:section name="Photography" id="{9cb5dd6b-e0aa-a768-7a9d-daee79a08d21}">
           <p14:sldIdLst>
             <p14:sldId id="262"/>
           </p14:sldIdLst>
         </p14:section>
-        <p14:section name="Next Steps" id="{2f032e5e-c5d8-7f30-4d66-e834e0649c05}">
+        <p14:section name="Next Steps" id="{af5bfe24-3529-5993-9e34-76aec9450ede}">
           <p14:sldIdLst>
             <p14:sldId id="263"/>
           </p14:sldIdLst>
         </p14:section>
-        <p14:section name="Closing" id="{8e3d0c95-edf3-9557-85bd-29f7b3045f2d}">
+        <p14:section name="Closing" id="{b79561ab-2642-dc65-3e4e-fc1906b3c1f4}">
           <p14:sldIdLst>
             <p14:sldId id="264"/>
           </p14:sldIdLst>
@@ -1004,7 +1004,7 @@
           <a:p>
             <a:r>
               <a:rPr lang="en-US" dirty="0"/>
-              <a:t>Highlight the three most impactful features. The live status bar is particularly powerful — it directly reduces unnecessary phone calls.</a:t>
+              <a:t>Highlight the four most impactful features. The live status bar and FAQ page both directly reduce unnecessary phone calls.</a:t>
             </a:r>
             <a:endParaRPr lang="en-US" dirty="0"/>
           </a:p>
@@ -4898,12 +4898,12 @@
         </p:nvSpPr>
         <p:spPr>
           <a:xfrm>
-            <a:off x="365760" y="1097280"/>
-            <a:ext cx="2651760" cy="3108960"/>
+            <a:off x="274320" y="1097280"/>
+            <a:ext cx="1965960" cy="3108960"/>
           </a:xfrm>
           <a:prstGeom prst="roundRect">
             <a:avLst>
-              <a:gd name="adj" fmla="val 4138"/>
+              <a:gd name="adj" fmla="val 5581"/>
             </a:avLst>
           </a:prstGeom>
           <a:solidFill>
@@ -4920,8 +4920,8 @@
         </p:nvSpPr>
         <p:spPr>
           <a:xfrm>
-            <a:off x="365760" y="1097280"/>
-            <a:ext cx="2651760" cy="54864"/>
+            <a:off x="274320" y="1097280"/>
+            <a:ext cx="1965960" cy="54864"/>
           </a:xfrm>
           <a:prstGeom prst="rect">
             <a:avLst/>
@@ -4940,8 +4940,8 @@
         </p:nvSpPr>
         <p:spPr>
           <a:xfrm>
-            <a:off x="548640" y="1325880"/>
-            <a:ext cx="2286000" cy="457200"/>
+            <a:off x="411480" y="1325880"/>
+            <a:ext cx="1691640" cy="457200"/>
           </a:xfrm>
           <a:prstGeom prst="rect">
             <a:avLst/>
@@ -4957,14 +4957,14 @@
               <a:buNone/>
             </a:pPr>
             <a:r>
-              <a:rPr lang="en-US" sz="1800" b="1" dirty="0">
+              <a:rPr lang="en-US" sz="1600" b="1" dirty="0">
                 <a:solidFill>
                   <a:srgbClr val="FFFFFF"/>
                 </a:solidFill>
               </a:rPr>
               <a:t>Live Status Bar</a:t>
             </a:r>
-            <a:endParaRPr lang="en-US" sz="1800" dirty="0"/>
+            <a:endParaRPr lang="en-US" sz="1600" dirty="0"/>
           </a:p>
         </p:txBody>
       </p:sp>
@@ -4976,8 +4976,8 @@
         </p:nvSpPr>
         <p:spPr>
           <a:xfrm>
-            <a:off x="548640" y="1874520"/>
-            <a:ext cx="2286000" cy="2103120"/>
+            <a:off x="411480" y="1874520"/>
+            <a:ext cx="1691640" cy="2103120"/>
           </a:xfrm>
           <a:prstGeom prst="rect">
             <a:avLst/>
@@ -4993,14 +4993,14 @@
               <a:buNone/>
             </a:pPr>
             <a:r>
-              <a:rPr lang="en-US" sz="1200" dirty="0">
+              <a:rPr lang="en-US" sz="1100" dirty="0">
                 <a:solidFill>
                   <a:srgbClr val="A1B2CE"/>
                 </a:solidFill>
               </a:rPr>
               <a:t>Shows whether you're open or closed right now, with today's hours — updates automatically. No more phone calls asking "are you open?"</a:t>
             </a:r>
-            <a:endParaRPr lang="en-US" sz="1200" dirty="0"/>
+            <a:endParaRPr lang="en-US" sz="1100" dirty="0"/>
           </a:p>
         </p:txBody>
       </p:sp>
@@ -5012,12 +5012,12 @@
         </p:nvSpPr>
         <p:spPr>
           <a:xfrm>
-            <a:off x="3246120" y="1097280"/>
-            <a:ext cx="2651760" cy="3108960"/>
+            <a:off x="2468880" y="1097280"/>
+            <a:ext cx="1965960" cy="3108960"/>
           </a:xfrm>
           <a:prstGeom prst="roundRect">
             <a:avLst>
-              <a:gd name="adj" fmla="val 4138"/>
+              <a:gd name="adj" fmla="val 5581"/>
             </a:avLst>
           </a:prstGeom>
           <a:solidFill>
@@ -5034,8 +5034,8 @@
         </p:nvSpPr>
         <p:spPr>
           <a:xfrm>
-            <a:off x="3246120" y="1097280"/>
-            <a:ext cx="2651760" cy="54864"/>
+            <a:off x="2468880" y="1097280"/>
+            <a:ext cx="1965960" cy="54864"/>
           </a:xfrm>
           <a:prstGeom prst="rect">
             <a:avLst/>
@@ -5054,8 +5054,8 @@
         </p:nvSpPr>
         <p:spPr>
           <a:xfrm>
-            <a:off x="3429000" y="1325880"/>
-            <a:ext cx="2286000" cy="457200"/>
+            <a:off x="2606040" y="1325880"/>
+            <a:ext cx="1691640" cy="457200"/>
           </a:xfrm>
           <a:prstGeom prst="rect">
             <a:avLst/>
@@ -5071,14 +5071,14 @@
               <a:buNone/>
             </a:pPr>
             <a:r>
-              <a:rPr lang="en-US" sz="1800" b="1" dirty="0">
+              <a:rPr lang="en-US" sz="1600" b="1" dirty="0">
                 <a:solidFill>
                   <a:srgbClr val="FFFFFF"/>
                 </a:solidFill>
               </a:rPr>
               <a:t>One-Tap Actions</a:t>
             </a:r>
-            <a:endParaRPr lang="en-US" sz="1800" dirty="0"/>
+            <a:endParaRPr lang="en-US" sz="1600" dirty="0"/>
           </a:p>
         </p:txBody>
       </p:sp>
@@ -5090,8 +5090,8 @@
         </p:nvSpPr>
         <p:spPr>
           <a:xfrm>
-            <a:off x="3429000" y="1874520"/>
-            <a:ext cx="2286000" cy="2103120"/>
+            <a:off x="2606040" y="1874520"/>
+            <a:ext cx="1691640" cy="2103120"/>
           </a:xfrm>
           <a:prstGeom prst="rect">
             <a:avLst/>
@@ -5107,14 +5107,14 @@
               <a:buNone/>
             </a:pPr>
             <a:r>
-              <a:rPr lang="en-US" sz="1200" dirty="0">
+              <a:rPr lang="en-US" sz="1100" dirty="0">
                 <a:solidFill>
                   <a:srgbClr val="A1B2CE"/>
                 </a:solidFill>
               </a:rPr>
               <a:t>Book a table, call the cafe, get directions, or download the PDF menu — all within one tap on any device</a:t>
             </a:r>
-            <a:endParaRPr lang="en-US" sz="1200" dirty="0"/>
+            <a:endParaRPr lang="en-US" sz="1100" dirty="0"/>
           </a:p>
         </p:txBody>
       </p:sp>
@@ -5126,12 +5126,12 @@
         </p:nvSpPr>
         <p:spPr>
           <a:xfrm>
-            <a:off x="6126480" y="1097280"/>
-            <a:ext cx="2651760" cy="3108960"/>
+            <a:off x="4663440" y="1097280"/>
+            <a:ext cx="1965960" cy="3108960"/>
           </a:xfrm>
           <a:prstGeom prst="roundRect">
             <a:avLst>
-              <a:gd name="adj" fmla="val 4138"/>
+              <a:gd name="adj" fmla="val 5581"/>
             </a:avLst>
           </a:prstGeom>
           <a:solidFill>
@@ -5148,8 +5148,122 @@
         </p:nvSpPr>
         <p:spPr>
           <a:xfrm>
-            <a:off x="6126480" y="1097280"/>
-            <a:ext cx="2651760" cy="54864"/>
+            <a:off x="4663440" y="1097280"/>
+            <a:ext cx="1965960" cy="54864"/>
+          </a:xfrm>
+          <a:prstGeom prst="rect">
+            <a:avLst/>
+          </a:prstGeom>
+          <a:solidFill>
+            <a:srgbClr val="FF9800"/>
+          </a:solidFill>
+          <a:ln/>
+        </p:spPr>
+      </p:sp>
+      <p:sp>
+        <p:nvSpPr>
+          <p:cNvPr id="13" name="Text 11"/>
+          <p:cNvSpPr txBox="1"/>
+          <p:nvPr/>
+        </p:nvSpPr>
+        <p:spPr>
+          <a:xfrm>
+            <a:off x="4800600" y="1325880"/>
+            <a:ext cx="1691640" cy="457200"/>
+          </a:xfrm>
+          <a:prstGeom prst="rect">
+            <a:avLst/>
+          </a:prstGeom>
+          <a:noFill/>
+          <a:ln/>
+        </p:spPr>
+        <p:txBody>
+          <a:bodyPr wrap="square" lIns="0" tIns="0" rIns="0" bIns="0" rtlCol="0" anchor="ctr"/>
+          <a:lstStyle/>
+          <a:p>
+            <a:pPr indent="0" marL="0">
+              <a:buNone/>
+            </a:pPr>
+            <a:r>
+              <a:rPr lang="en-US" sz="1600" b="1" dirty="0">
+                <a:solidFill>
+                  <a:srgbClr val="FFFFFF"/>
+                </a:solidFill>
+              </a:rPr>
+              <a:t>Smart Navigation</a:t>
+            </a:r>
+            <a:endParaRPr lang="en-US" sz="1600" dirty="0"/>
+          </a:p>
+        </p:txBody>
+      </p:sp>
+      <p:sp>
+        <p:nvSpPr>
+          <p:cNvPr id="14" name="Text 12"/>
+          <p:cNvSpPr txBox="1"/>
+          <p:nvPr/>
+        </p:nvSpPr>
+        <p:spPr>
+          <a:xfrm>
+            <a:off x="4800600" y="1874520"/>
+            <a:ext cx="1691640" cy="2103120"/>
+          </a:xfrm>
+          <a:prstGeom prst="rect">
+            <a:avLst/>
+          </a:prstGeom>
+          <a:noFill/>
+          <a:ln/>
+        </p:spPr>
+        <p:txBody>
+          <a:bodyPr wrap="square" lIns="0" tIns="0" rIns="0" bIns="0" rtlCol="0" anchor="t"/>
+          <a:lstStyle/>
+          <a:p>
+            <a:pPr indent="0" marL="0">
+              <a:buNone/>
+            </a:pPr>
+            <a:r>
+              <a:rPr lang="en-US" sz="1100" dirty="0">
+                <a:solidFill>
+                  <a:srgbClr val="A1B2CE"/>
+                </a:solidFill>
+              </a:rPr>
+              <a:t>Sticky header with quick links to every section. Visitors find what they need without scrolling — menus, booking, directions, all one tap away</a:t>
+            </a:r>
+            <a:endParaRPr lang="en-US" sz="1100" dirty="0"/>
+          </a:p>
+        </p:txBody>
+      </p:sp>
+      <p:sp>
+        <p:nvSpPr>
+          <p:cNvPr id="15" name="Shape 13"/>
+          <p:cNvSpPr/>
+          <p:nvPr/>
+        </p:nvSpPr>
+        <p:spPr>
+          <a:xfrm>
+            <a:off x="6858000" y="1097280"/>
+            <a:ext cx="1965960" cy="3108960"/>
+          </a:xfrm>
+          <a:prstGeom prst="roundRect">
+            <a:avLst>
+              <a:gd name="adj" fmla="val 5581"/>
+            </a:avLst>
+          </a:prstGeom>
+          <a:solidFill>
+            <a:srgbClr val="3D5A80"/>
+          </a:solidFill>
+          <a:ln/>
+        </p:spPr>
+      </p:sp>
+      <p:sp>
+        <p:nvSpPr>
+          <p:cNvPr id="16" name="Shape 14"/>
+          <p:cNvSpPr/>
+          <p:nvPr/>
+        </p:nvSpPr>
+        <p:spPr>
+          <a:xfrm>
+            <a:off x="6858000" y="1097280"/>
+            <a:ext cx="1965960" cy="54864"/>
           </a:xfrm>
           <a:prstGeom prst="rect">
             <a:avLst/>
@@ -5162,14 +5276,14 @@
       </p:sp>
       <p:sp>
         <p:nvSpPr>
-          <p:cNvPr id="13" name="Text 11"/>
-          <p:cNvSpPr txBox="1"/>
-          <p:nvPr/>
-        </p:nvSpPr>
-        <p:spPr>
-          <a:xfrm>
-            <a:off x="6309360" y="1325880"/>
-            <a:ext cx="2286000" cy="457200"/>
+          <p:cNvPr id="17" name="Text 15"/>
+          <p:cNvSpPr txBox="1"/>
+          <p:nvPr/>
+        </p:nvSpPr>
+        <p:spPr>
+          <a:xfrm>
+            <a:off x="6995160" y="1325880"/>
+            <a:ext cx="1691640" cy="457200"/>
           </a:xfrm>
           <a:prstGeom prst="rect">
             <a:avLst/>
@@ -5185,27 +5299,27 @@
               <a:buNone/>
             </a:pPr>
             <a:r>
-              <a:rPr lang="en-US" sz="1800" b="1" dirty="0">
+              <a:rPr lang="en-US" sz="1600" b="1" dirty="0">
                 <a:solidFill>
                   <a:srgbClr val="FFFFFF"/>
                 </a:solidFill>
               </a:rPr>
               <a:t>FAQ Page</a:t>
             </a:r>
-            <a:endParaRPr lang="en-US" sz="1800" dirty="0"/>
-          </a:p>
-        </p:txBody>
-      </p:sp>
-      <p:sp>
-        <p:nvSpPr>
-          <p:cNvPr id="14" name="Text 12"/>
-          <p:cNvSpPr txBox="1"/>
-          <p:nvPr/>
-        </p:nvSpPr>
-        <p:spPr>
-          <a:xfrm>
-            <a:off x="6309360" y="1874520"/>
-            <a:ext cx="2286000" cy="2103120"/>
+            <a:endParaRPr lang="en-US" sz="1600" dirty="0"/>
+          </a:p>
+        </p:txBody>
+      </p:sp>
+      <p:sp>
+        <p:nvSpPr>
+          <p:cNvPr id="18" name="Text 16"/>
+          <p:cNvSpPr txBox="1"/>
+          <p:nvPr/>
+        </p:nvSpPr>
+        <p:spPr>
+          <a:xfrm>
+            <a:off x="6995160" y="1874520"/>
+            <a:ext cx="1691640" cy="2103120"/>
           </a:xfrm>
           <a:prstGeom prst="rect">
             <a:avLst/>
@@ -5221,14 +5335,14 @@
               <a:buNone/>
             </a:pPr>
             <a:r>
-              <a:rPr lang="en-US" sz="1200" dirty="0">
+              <a:rPr lang="en-US" sz="1100" dirty="0">
                 <a:solidFill>
                   <a:srgbClr val="A1B2CE"/>
                 </a:solidFill>
               </a:rPr>
               <a:t>Dogs, parking, groups, allergens — all answered on one page. Fewer calls about the basics means more time for your customers</a:t>
             </a:r>
-            <a:endParaRPr lang="en-US" sz="1200" dirty="0"/>
+            <a:endParaRPr lang="en-US" sz="1100" dirty="0"/>
           </a:p>
         </p:txBody>
       </p:sp>

</xml_diff>

<commit_message>
Split closing slide heading into two lines: Ready, / when you are.
Co-Authored-By: Claude Opus 4.6 <noreply@anthropic.com>
Claude-Session: https://claude.ai/code/session_012ZbjzZ7aoL8AUKXKQXjSCU
</commit_message>
<xml_diff>
--- a/SeaShanty_Redesign_Pitch.pptx
+++ b/SeaShanty_Redesign_Pitch.pptx
@@ -115,47 +115,47 @@
   <p:extLst>
     <p:ext uri="{521415D9-36F7-43E2-AB2F-B90AF26B5E84}">
       <p14:sectionLst xmlns:p14="http://schemas.microsoft.com/office/powerpoint/2010/main">
-        <p14:section name="Introduction" id="{1d7e79f3-8d83-8b71-4b5c-31b9e54a91d3}">
+        <p14:section name="Introduction" id="{ba518b05-1097-ea00-0dbf-48a827416fea}">
           <p14:sldIdLst>
             <p14:sldId id="256"/>
           </p14:sldIdLst>
         </p14:section>
-        <p14:section name="The Problem" id="{50ecd757-35ae-e48f-e99c-3c63a5957a2c}">
+        <p14:section name="The Problem" id="{b6936c2d-85a0-ce40-d491-4f4d040a900d}">
           <p14:sldIdLst>
             <p14:sldId id="257"/>
           </p14:sldIdLst>
         </p14:section>
-        <p14:section name="Before and After" id="{4bcc15e9-8b1a-55be-2b63-774e890aaa7e}">
+        <p14:section name="Before and After" id="{9d5ba7f1-0a9c-f520-80fb-ce4df1dffb61}">
           <p14:sldIdLst>
             <p14:sldId id="258"/>
           </p14:sldIdLst>
         </p14:section>
-        <p14:section name="Why It Matters" id="{4030c79f-7fe8-6a17-dacc-b74a80c9490b}">
+        <p14:section name="Why It Matters" id="{fdd4bedd-ef42-9e25-58a7-47f8263694b1}">
           <p14:sldIdLst>
             <p14:sldId id="259"/>
           </p14:sldIdLst>
         </p14:section>
-        <p14:section name="What's Included" id="{4b1e712b-0698-73a4-ab63-5ea24ea21a68}">
+        <p14:section name="What's Included" id="{b61eb5f8-22de-b398-4021-cae5a58a223d}">
           <p14:sldIdLst>
             <p14:sldId id="260"/>
           </p14:sldIdLst>
         </p14:section>
-        <p14:section name="Key Features" id="{a47b80c9-d777-ff0a-45da-a9f6de0a198f}">
+        <p14:section name="Key Features" id="{98828013-cbde-7cdf-46d1-4e834265966e}">
           <p14:sldIdLst>
             <p14:sldId id="261"/>
           </p14:sldIdLst>
         </p14:section>
-        <p14:section name="Photography" id="{9cb5dd6b-e0aa-a768-7a9d-daee79a08d21}">
+        <p14:section name="Photography" id="{4fd31c84-ef17-39aa-b762-59589f461874}">
           <p14:sldIdLst>
             <p14:sldId id="262"/>
           </p14:sldIdLst>
         </p14:section>
-        <p14:section name="Next Steps" id="{af5bfe24-3529-5993-9e34-76aec9450ede}">
+        <p14:section name="Next Steps" id="{3e2f0ebe-85ec-5d01-cb9f-ecc0fb9be757}">
           <p14:sldIdLst>
             <p14:sldId id="263"/>
           </p14:sldIdLst>
         </p14:section>
-        <p14:section name="Closing" id="{b79561ab-2642-dc65-3e4e-fc1906b3c1f4}">
+        <p14:section name="Closing" id="{665968ab-be30-3c88-bb66-b7b71e166baf}">
           <p14:sldIdLst>
             <p14:sldId id="264"/>
           </p14:sldIdLst>
@@ -6924,8 +6924,8 @@
         </p:nvSpPr>
         <p:spPr>
           <a:xfrm>
-            <a:off x="731520" y="731520"/>
-            <a:ext cx="3840480" cy="1005840"/>
+            <a:off x="731520" y="640080"/>
+            <a:ext cx="3840480" cy="1097280"/>
           </a:xfrm>
           <a:prstGeom prst="rect">
             <a:avLst/>
@@ -6946,7 +6946,21 @@
                   <a:srgbClr val="FFFFFF"/>
                 </a:solidFill>
               </a:rPr>
-              <a:t>Ready when you are.</a:t>
+              <a:t>Ready,</a:t>
+            </a:r>
+            <a:endParaRPr lang="en-US" sz="3800" dirty="0"/>
+          </a:p>
+          <a:p>
+            <a:pPr indent="0" marL="0">
+              <a:buNone/>
+            </a:pPr>
+            <a:r>
+              <a:rPr lang="en-US" sz="3800" b="1" dirty="0">
+                <a:solidFill>
+                  <a:srgbClr val="FFFFFF"/>
+                </a:solidFill>
+              </a:rPr>
+              <a:t>when you are.</a:t>
             </a:r>
             <a:endParaRPr lang="en-US" sz="3800" dirty="0"/>
           </a:p>

</xml_diff>